<commit_message>
Update slide deck for ai dev gallery
</commit_message>
<xml_diff>
--- a/2026/0426_AIDevConf/ai-dev-gallery.pptx
+++ b/2026/0426_AIDevConf/ai-dev-gallery.pptx
@@ -4,6 +4,9 @@
   <p:sldMasterIdLst>
     <p:sldMasterId id="2147483648" r:id="rId1"/>
   </p:sldMasterIdLst>
+  <p:notesMasterIdLst>
+    <p:notesMasterId r:id="rId10"/>
+  </p:notesMasterIdLst>
   <p:sldIdLst>
     <p:sldId id="256" r:id="rId2"/>
     <p:sldId id="257" r:id="rId3"/>
@@ -14,9 +17,6 @@
     <p:sldId id="262" r:id="rId8"/>
     <p:sldId id="263" r:id="rId9"/>
   </p:sldIdLst>
-  <p:notesMasterIdLst>
-    <p:notesMasterId r:id="rId10"/>
-  </p:notesMasterIdLst>
   <p:sldSz cx="12192000" cy="6858000"/>
   <p:notesSz cx="6858000" cy="12192000"/>
   <p:defaultTextStyle>
@@ -111,6 +111,11 @@
       </a:defRPr>
     </a:lvl9pPr>
   </p:defaultTextStyle>
+  <p:extLst>
+    <p:ext uri="{EFAFB233-063F-42B5-8137-9DF3F51BA10A}">
+      <p15:sldGuideLst xmlns:p15="http://schemas.microsoft.com/office/powerpoint/2012/main"/>
+    </p:ext>
+  </p:extLst>
 </p:presentation>
 </file>
 
@@ -136,234 +141,10 @@
           <a:chExt cx="0" cy="0"/>
         </a:xfrm>
       </p:grpSpPr>
-      <p:sp>
-        <p:nvSpPr>
-          <p:cNvPr id="2" name="Header Placeholder 1"/>
-          <p:cNvSpPr>
-            <a:spLocks noGrp="1"/>
-          </p:cNvSpPr>
-          <p:nvPr>
-            <p:ph type="hdr" sz="quarter"/>
-          </p:nvPr>
-        </p:nvSpPr>
-        <p:spPr>
-          <a:xfrm>
-            <a:off x="0" y="0"/>
-            <a:ext cx="2971800" cy="458788"/>
-          </a:xfrm>
-          <a:prstGeom prst="rect">
-            <a:avLst/>
-          </a:prstGeom>
-        </p:spPr>
-        <p:txBody>
-          <a:bodyPr vert="horz" lIns="91440" tIns="45720" rIns="91440" bIns="45720" rtlCol="0"/>
-          <a:lstStyle>
-            <a:lvl1pPr algn="l">
-              <a:defRPr sz="1200"/>
-            </a:lvl1pPr>
-          </a:lstStyle>
-          <a:p>
-            <a:endParaRPr lang="en-US"/>
-          </a:p>
-        </p:txBody>
-      </p:sp>
-      <p:sp>
-        <p:nvSpPr>
-          <p:cNvPr id="3" name="Date Placeholder 2"/>
-          <p:cNvSpPr>
-            <a:spLocks noGrp="1"/>
-          </p:cNvSpPr>
-          <p:nvPr>
-            <p:ph type="dt" idx="1"/>
-          </p:nvPr>
-        </p:nvSpPr>
-        <p:spPr>
-          <a:xfrm>
-            <a:off x="3884613" y="0"/>
-            <a:ext cx="2971800" cy="458788"/>
-          </a:xfrm>
-          <a:prstGeom prst="rect">
-            <a:avLst/>
-          </a:prstGeom>
-        </p:spPr>
-        <p:txBody>
-          <a:bodyPr vert="horz" lIns="91440" tIns="45720" rIns="91440" bIns="45720" rtlCol="0"/>
-          <a:lstStyle>
-            <a:lvl1pPr algn="r">
-              <a:defRPr sz="1200"/>
-            </a:lvl1pPr>
-          </a:lstStyle>
-          <a:p>
-            <a:fld id="{5282F153-3F37-0F45-9E97-73ACFA13230C}" type="datetimeFigureOut">
-              <a:rPr lang="en-US"/>
-              <a:t>7/23/19</a:t>
-            </a:fld>
-            <a:endParaRPr lang="en-US"/>
-          </a:p>
-        </p:txBody>
-      </p:sp>
-      <p:sp>
-        <p:nvSpPr>
-          <p:cNvPr id="4" name="Slide Image Placeholder 3"/>
-          <p:cNvSpPr>
-            <a:spLocks noGrp="1" noRot="1" noChangeAspect="1"/>
-          </p:cNvSpPr>
-          <p:nvPr>
-            <p:ph type="sldImg" idx="2"/>
-          </p:nvPr>
-        </p:nvSpPr>
-        <p:spPr>
-          <a:xfrm>
-            <a:off x="685800" y="1143000"/>
-            <a:ext cx="5486400" cy="3086100"/>
-          </a:xfrm>
-          <a:prstGeom prst="rect">
-            <a:avLst/>
-          </a:prstGeom>
-          <a:noFill/>
-          <a:ln w="12700">
-            <a:solidFill>
-              <a:prstClr val="black"/>
-            </a:solidFill>
-          </a:ln>
-        </p:spPr>
-        <p:txBody>
-          <a:bodyPr vert="horz" lIns="91440" tIns="45720" rIns="91440" bIns="45720" rtlCol="0" anchor="ctr"/>
-          <a:lstStyle/>
-          <a:p>
-            <a:endParaRPr lang="en-US"/>
-          </a:p>
-        </p:txBody>
-      </p:sp>
-      <p:sp>
-        <p:nvSpPr>
-          <p:cNvPr id="5" name="Notes Placeholder 4"/>
-          <p:cNvSpPr>
-            <a:spLocks noGrp="1"/>
-          </p:cNvSpPr>
-          <p:nvPr>
-            <p:ph type="body" sz="quarter" idx="3"/>
-          </p:nvPr>
-        </p:nvSpPr>
-        <p:spPr>
-          <a:xfrm>
-            <a:off x="685800" y="4400550"/>
-            <a:ext cx="5486400" cy="3600450"/>
-          </a:xfrm>
-          <a:prstGeom prst="rect">
-            <a:avLst/>
-          </a:prstGeom>
-        </p:spPr>
-        <p:txBody>
-          <a:bodyPr vert="horz" lIns="91440" tIns="45720" rIns="91440" bIns="45720" rtlCol="0"/>
-          <a:lstStyle/>
-          <a:p>
-            <a:pPr lvl="0"/>
-            <a:r>
-              <a:rPr lang="en-US"/>
-              <a:t>Click to edit Master text styles</a:t>
-            </a:r>
-          </a:p>
-          <a:p>
-            <a:pPr lvl="1"/>
-            <a:r>
-              <a:rPr lang="en-US"/>
-              <a:t>Second level</a:t>
-            </a:r>
-          </a:p>
-          <a:p>
-            <a:pPr lvl="2"/>
-            <a:r>
-              <a:rPr lang="en-US"/>
-              <a:t>Third level</a:t>
-            </a:r>
-          </a:p>
-          <a:p>
-            <a:pPr lvl="3"/>
-            <a:r>
-              <a:rPr lang="en-US"/>
-              <a:t>Fourth level</a:t>
-            </a:r>
-          </a:p>
-          <a:p>
-            <a:pPr lvl="4"/>
-            <a:r>
-              <a:rPr lang="en-US"/>
-              <a:t>Fifth level</a:t>
-            </a:r>
-          </a:p>
-        </p:txBody>
-      </p:sp>
-      <p:sp>
-        <p:nvSpPr>
-          <p:cNvPr id="6" name="Footer Placeholder 5"/>
-          <p:cNvSpPr>
-            <a:spLocks noGrp="1"/>
-          </p:cNvSpPr>
-          <p:nvPr>
-            <p:ph type="ftr" sz="quarter" idx="4"/>
-          </p:nvPr>
-        </p:nvSpPr>
-        <p:spPr>
-          <a:xfrm>
-            <a:off x="0" y="8685213"/>
-            <a:ext cx="2971800" cy="458787"/>
-          </a:xfrm>
-          <a:prstGeom prst="rect">
-            <a:avLst/>
-          </a:prstGeom>
-        </p:spPr>
-        <p:txBody>
-          <a:bodyPr vert="horz" lIns="91440" tIns="45720" rIns="91440" bIns="45720" rtlCol="0" anchor="b"/>
-          <a:lstStyle>
-            <a:lvl1pPr algn="l">
-              <a:defRPr sz="1200"/>
-            </a:lvl1pPr>
-          </a:lstStyle>
-          <a:p>
-            <a:endParaRPr lang="en-US"/>
-          </a:p>
-        </p:txBody>
-      </p:sp>
-      <p:sp>
-        <p:nvSpPr>
-          <p:cNvPr id="7" name="Slide Number Placeholder 6"/>
-          <p:cNvSpPr>
-            <a:spLocks noGrp="1"/>
-          </p:cNvSpPr>
-          <p:nvPr>
-            <p:ph type="sldNum" sz="quarter" idx="5"/>
-          </p:nvPr>
-        </p:nvSpPr>
-        <p:spPr>
-          <a:xfrm>
-            <a:off x="3884613" y="8685213"/>
-            <a:ext cx="2971800" cy="458787"/>
-          </a:xfrm>
-          <a:prstGeom prst="rect">
-            <a:avLst/>
-          </a:prstGeom>
-        </p:spPr>
-        <p:txBody>
-          <a:bodyPr vert="horz" lIns="91440" tIns="45720" rIns="91440" bIns="45720" rtlCol="0" anchor="b"/>
-          <a:lstStyle>
-            <a:lvl1pPr algn="r">
-              <a:defRPr sz="1200"/>
-            </a:lvl1pPr>
-          </a:lstStyle>
-          <a:p>
-            <a:fld id="{CE5E9CC1-C706-0F49-92D6-E571CC5EEA8F}" type="slidenum">
-              <a:rPr lang="en-US"/>
-              <a:t>‹#›</a:t>
-            </a:fld>
-            <a:endParaRPr lang="en-US"/>
-          </a:p>
-        </p:txBody>
-      </p:sp>
     </p:spTree>
     <p:extLst>
       <p:ext uri="{BB962C8B-B14F-4D97-AF65-F5344CB8AC3E}">
-        <p14:creationId xmlns:p14="http://schemas.microsoft.com/office/powerpoint/2010/main" val="1024086991"/>
+        <p14:creationId xmlns:p14="http://schemas.microsoft.com/office/powerpoint/2010/main" val="2585204567"/>
       </p:ext>
     </p:extLst>
   </p:cSld>
@@ -507,10 +288,6 @@
           <a:bodyPr/>
           <a:lstStyle/>
           <a:p>
-            <a:r>
-              <a:rPr lang="en-US" dirty="0"/>
-              <a:t/>
-            </a:r>
             <a:endParaRPr lang="en-US" dirty="0"/>
           </a:p>
         </p:txBody>
@@ -595,10 +372,6 @@
           <a:bodyPr/>
           <a:lstStyle/>
           <a:p>
-            <a:r>
-              <a:rPr lang="en-US" dirty="0"/>
-              <a:t/>
-            </a:r>
             <a:endParaRPr lang="en-US" dirty="0"/>
           </a:p>
         </p:txBody>
@@ -683,10 +456,6 @@
           <a:bodyPr/>
           <a:lstStyle/>
           <a:p>
-            <a:r>
-              <a:rPr lang="en-US" dirty="0"/>
-              <a:t/>
-            </a:r>
             <a:endParaRPr lang="en-US" dirty="0"/>
           </a:p>
         </p:txBody>
@@ -771,10 +540,6 @@
           <a:bodyPr/>
           <a:lstStyle/>
           <a:p>
-            <a:r>
-              <a:rPr lang="en-US" dirty="0"/>
-              <a:t/>
-            </a:r>
             <a:endParaRPr lang="en-US" dirty="0"/>
           </a:p>
         </p:txBody>
@@ -859,10 +624,6 @@
           <a:bodyPr/>
           <a:lstStyle/>
           <a:p>
-            <a:r>
-              <a:rPr lang="en-US" dirty="0"/>
-              <a:t/>
-            </a:r>
             <a:endParaRPr lang="en-US" dirty="0"/>
           </a:p>
         </p:txBody>
@@ -947,10 +708,6 @@
           <a:bodyPr/>
           <a:lstStyle/>
           <a:p>
-            <a:r>
-              <a:rPr lang="en-US" dirty="0"/>
-              <a:t/>
-            </a:r>
             <a:endParaRPr lang="en-US" dirty="0"/>
           </a:p>
         </p:txBody>
@@ -1035,10 +792,6 @@
           <a:bodyPr/>
           <a:lstStyle/>
           <a:p>
-            <a:r>
-              <a:rPr lang="en-US" dirty="0"/>
-              <a:t/>
-            </a:r>
             <a:endParaRPr lang="en-US" dirty="0"/>
           </a:p>
         </p:txBody>
@@ -1123,10 +876,6 @@
           <a:bodyPr/>
           <a:lstStyle/>
           <a:p>
-            <a:r>
-              <a:rPr lang="en-US" dirty="0"/>
-              <a:t/>
-            </a:r>
             <a:endParaRPr lang="en-US" dirty="0"/>
           </a:p>
         </p:txBody>
@@ -1209,7 +958,7 @@
           </a:prstGeom>
           <a:extLst>
             <a:ext uri="{C572A759-6A51-4108-AA02-DFA0A04FC94B}">
-              <ma14:wrappingTextBoxFlag xmlns:ma14="http://schemas.microsoft.com/office/mac/drawingml/2011/main" val="0"/>
+              <ma14:wrappingTextBoxFlag xmlns:ma14="http://schemas.microsoft.com/office/mac/drawingml/2011/main" xmlns="" val="0"/>
             </a:ext>
           </a:extLst>
         </p:spPr>
@@ -1227,8 +976,8 @@
           <a:p>
             <a:pPr algn="r"/>
             <a:fld id="{F7021451-1387-4CA6-816F-3879F97B5CBC}" type="slidenum">
-              <a:rPr b="0" lang="en-US"/>
-              <a:t>1000</a:t>
+              <a:rPr lang="en-US" b="0"/>
+              <a:t>‹#›</a:t>
             </a:fld>
             <a:endParaRPr lang="en-US"/>
           </a:p>
@@ -1245,6 +994,11 @@
 <file path=ppt/slideMasters/slideMaster1.xml><?xml version="1.0" encoding="utf-8"?>
 <p:sldMaster xmlns:a="http://schemas.openxmlformats.org/drawingml/2006/main" xmlns:r="http://schemas.openxmlformats.org/officeDocument/2006/relationships" xmlns:p="http://schemas.openxmlformats.org/presentationml/2006/main">
   <p:cSld>
+    <p:bg>
+      <p:bgRef idx="1001">
+        <a:schemeClr val="bg1"/>
+      </p:bgRef>
+    </p:bg>
     <p:spTree>
       <p:nvGrpSpPr>
         <p:cNvPr id="1" name=""/>
@@ -1279,7 +1033,7 @@
           </a:prstGeom>
           <a:extLst>
             <a:ext uri="{C572A759-6A51-4108-AA02-DFA0A04FC94B}">
-              <ma14:wrappingTextBoxFlag xmlns:ma14="http://schemas.microsoft.com/office/mac/drawingml/2011/main" val="0"/>
+              <ma14:wrappingTextBoxFlag xmlns:ma14="http://schemas.microsoft.com/office/mac/drawingml/2011/main" xmlns="" val="0"/>
             </a:ext>
           </a:extLst>
         </p:spPr>
@@ -1297,8 +1051,8 @@
           <a:p>
             <a:pPr algn="r"/>
             <a:fld id="{F7021451-1387-4CA6-816F-3879F97B5CBC}" type="slidenum">
-              <a:rPr b="0" lang="en-US"/>
-              <a:t>null</a:t>
+              <a:rPr lang="en-US" b="0"/>
+              <a:t>‹#›</a:t>
             </a:fld>
             <a:endParaRPr lang="en-US"/>
           </a:p>
@@ -1570,7 +1324,7 @@
     <p:bg>
       <p:bgPr>
         <a:blipFill dpi="0" rotWithShape="1">
-          <a:blip r:embed="rId1">
+          <a:blip r:embed="rId3">
             <a:lum/>
           </a:blip>
           <a:srcRect/>
@@ -1616,14 +1370,14 @@
           <a:bodyPr wrap="square" lIns="0" tIns="0" rIns="0" bIns="0" rtlCol="0" anchor="t"/>
           <a:lstStyle/>
           <a:p>
-            <a:pPr algn="ctr" indent="0" marL="0">
+            <a:pPr marL="0" indent="0" algn="ctr">
               <a:lnSpc>
                 <a:spcPct val="135000"/>
               </a:lnSpc>
               <a:buNone/>
             </a:pPr>
             <a:r>
-              <a:rPr lang="en-US" sz="4725" b="1" spc="94" kern="0" dirty="0">
+              <a:rPr lang="en-US" sz="4725" b="1" kern="0" spc="94" dirty="0">
                 <a:solidFill>
                   <a:srgbClr val="FFF8E1"/>
                 </a:solidFill>
@@ -1645,7 +1399,7 @@
         </p:nvSpPr>
         <p:spPr>
           <a:xfrm>
-            <a:off x="666750" y="3715643"/>
+            <a:off x="666750" y="4078807"/>
             <a:ext cx="11372850" cy="585043"/>
           </a:xfrm>
           <a:prstGeom prst="rect">
@@ -1658,14 +1412,14 @@
           <a:bodyPr wrap="square" lIns="0" tIns="0" rIns="0" bIns="0" rtlCol="0" anchor="t"/>
           <a:lstStyle/>
           <a:p>
-            <a:pPr algn="ctr" indent="0" marL="0">
+            <a:pPr marL="0" indent="0" algn="ctr">
               <a:lnSpc>
                 <a:spcPct val="135000"/>
               </a:lnSpc>
               <a:buNone/>
             </a:pPr>
             <a:r>
-              <a:rPr lang="en-US" sz="3413" b="1" spc="94" kern="0" dirty="0">
+              <a:rPr lang="en-US" sz="3413" b="1" kern="0" spc="94" dirty="0">
                 <a:solidFill>
                   <a:srgbClr val="FFF8E1"/>
                 </a:solidFill>
@@ -1687,7 +1441,7 @@
         </p:nvSpPr>
         <p:spPr>
           <a:xfrm>
-            <a:off x="666750" y="4484043"/>
+            <a:off x="666750" y="4847207"/>
             <a:ext cx="11372850" cy="495002"/>
           </a:xfrm>
           <a:prstGeom prst="rect">
@@ -1700,14 +1454,14 @@
           <a:bodyPr wrap="square" lIns="0" tIns="0" rIns="0" bIns="0" rtlCol="0" anchor="t"/>
           <a:lstStyle/>
           <a:p>
-            <a:pPr algn="ctr" indent="0" marL="0">
+            <a:pPr marL="0" indent="0" algn="ctr">
               <a:lnSpc>
                 <a:spcPct val="135000"/>
               </a:lnSpc>
               <a:buNone/>
             </a:pPr>
             <a:r>
-              <a:rPr lang="en-US" sz="2888" b="1" spc="94" kern="0" dirty="0">
+              <a:rPr lang="en-US" sz="2888" b="1" kern="0" spc="94" dirty="0">
                 <a:solidFill>
                   <a:srgbClr val="FFF8E1"/>
                 </a:solidFill>
@@ -1715,7 +1469,7 @@
                 <a:ea typeface="Lato" pitchFamily="34" charset="-122"/>
                 <a:cs typeface="Lato" pitchFamily="34" charset="-120"/>
               </a:rPr>
-              <a:t>April 26, 2026</a:t>
+              <a:t>Sr. Content Developer - Microsoft</a:t>
             </a:r>
             <a:endParaRPr lang="en-US" sz="2888" dirty="0"/>
           </a:p>
@@ -1741,7 +1495,7 @@
           </a:prstGeom>
           <a:extLst>
             <a:ext uri="{C572A759-6A51-4108-AA02-DFA0A04FC94B}">
-              <ma14:wrappingTextBoxFlag xmlns:ma14="http://schemas.microsoft.com/office/mac/drawingml/2011/main" val="0"/>
+              <ma14:wrappingTextBoxFlag xmlns:ma14="http://schemas.microsoft.com/office/mac/drawingml/2011/main" xmlns="" val="0"/>
             </a:ext>
           </a:extLst>
         </p:spPr>
@@ -1759,7 +1513,7 @@
           <a:p>
             <a:pPr algn="r"/>
             <a:fld id="{F7021451-1387-4CA6-816F-3879F97B5CBC}" type="slidenum">
-              <a:rPr b="0" lang="en-US"/>
+              <a:rPr lang="en-US" b="0"/>
               <a:t>1</a:t>
             </a:fld>
             <a:endParaRPr lang="en-US"/>
@@ -1780,7 +1534,7 @@
     <p:bg>
       <p:bgPr>
         <a:blipFill dpi="0" rotWithShape="1">
-          <a:blip r:embed="rId1">
+          <a:blip r:embed="rId3">
             <a:lum/>
           </a:blip>
           <a:srcRect/>
@@ -1826,14 +1580,14 @@
           <a:bodyPr wrap="square" lIns="0" tIns="0" rIns="0" bIns="0" rtlCol="0" anchor="t"/>
           <a:lstStyle/>
           <a:p>
-            <a:pPr algn="l" indent="0" marL="0">
+            <a:pPr marL="0" indent="0" algn="l">
               <a:lnSpc>
                 <a:spcPct val="216000"/>
               </a:lnSpc>
               <a:buNone/>
             </a:pPr>
             <a:r>
-              <a:rPr lang="en-US" sz="1733" b="1" spc="94" kern="0" dirty="0">
+              <a:rPr lang="en-US" sz="1733" b="1" kern="0" spc="94" dirty="0">
                 <a:solidFill>
                   <a:srgbClr val="6A7A7D"/>
                 </a:solidFill>
@@ -1868,14 +1622,14 @@
           <a:bodyPr wrap="square" lIns="0" tIns="0" rIns="0" bIns="0" rtlCol="0" anchor="t"/>
           <a:lstStyle/>
           <a:p>
-            <a:pPr algn="l" indent="0" marL="0">
+            <a:pPr marL="0" indent="0" algn="l">
               <a:lnSpc>
                 <a:spcPct val="135000"/>
               </a:lnSpc>
               <a:buNone/>
             </a:pPr>
             <a:r>
-              <a:rPr lang="en-US" sz="3938" b="1" spc="94" kern="0" dirty="0">
+              <a:rPr lang="en-US" sz="3938" b="1" kern="0" spc="94" dirty="0">
                 <a:solidFill>
                   <a:srgbClr val="455A64"/>
                 </a:solidFill>
@@ -1898,7 +1652,7 @@
         <p:spPr>
           <a:xfrm>
             <a:off x="666750" y="1675209"/>
-            <a:ext cx="10858500" cy="1000125"/>
+            <a:ext cx="10858500" cy="1753791"/>
           </a:xfrm>
           <a:prstGeom prst="rect">
             <a:avLst/>
@@ -1910,7 +1664,7 @@
           <a:bodyPr wrap="square" lIns="0" tIns="0" rIns="0" bIns="0" rtlCol="0" anchor="t"/>
           <a:lstStyle/>
           <a:p>
-            <a:pPr algn="l" marL="342900" indent="-342900">
+            <a:pPr marL="342900" indent="-342900" algn="l">
               <a:lnSpc>
                 <a:spcPct val="135000"/>
               </a:lnSpc>
@@ -1918,7 +1672,7 @@
               <a:buChar char="•"/>
             </a:pPr>
             <a:r>
-              <a:rPr lang="en-US" sz="2625" b="1" spc="94" kern="0" dirty="0">
+              <a:rPr lang="en-US" sz="2625" b="1" kern="0" spc="94" dirty="0">
                 <a:solidFill>
                   <a:srgbClr val="455A64"/>
                 </a:solidFill>
@@ -1931,7 +1685,7 @@
             <a:endParaRPr lang="en-US" sz="2625" dirty="0"/>
           </a:p>
           <a:p>
-            <a:pPr algn="l" marL="342900" indent="-342900">
+            <a:pPr marL="342900" indent="-342900" algn="l">
               <a:lnSpc>
                 <a:spcPct val="135000"/>
               </a:lnSpc>
@@ -1939,7 +1693,7 @@
               <a:buChar char="•"/>
             </a:pPr>
             <a:r>
-              <a:rPr lang="en-US" sz="2625" spc="94" kern="0" dirty="0">
+              <a:rPr lang="en-US" sz="2625" kern="0" spc="94" dirty="0">
                 <a:solidFill>
                   <a:srgbClr val="455A64"/>
                 </a:solidFill>
@@ -1948,6 +1702,26 @@
                 <a:cs typeface="Lato" pitchFamily="34" charset="-120"/>
               </a:rPr>
               <a:t>Sr. Content Developer — Microsoft Learn</a:t>
+            </a:r>
+          </a:p>
+          <a:p>
+            <a:pPr marL="800100" lvl="1" indent="-342900">
+              <a:lnSpc>
+                <a:spcPct val="135000"/>
+              </a:lnSpc>
+              <a:buSzPct val="100000"/>
+              <a:buChar char="•"/>
+            </a:pPr>
+            <a:r>
+              <a:rPr lang="en-US" sz="2625" kern="0" spc="94" dirty="0">
+                <a:solidFill>
+                  <a:srgbClr val="455A64"/>
+                </a:solidFill>
+                <a:latin typeface="Lato" pitchFamily="34" charset="0"/>
+                <a:ea typeface="Lato" pitchFamily="34" charset="-122"/>
+                <a:cs typeface="Lato" pitchFamily="34" charset="-120"/>
+              </a:rPr>
+              <a:t>Microsoft Foundry documentation (Agent services &amp; OpenAI)</a:t>
             </a:r>
             <a:endParaRPr lang="en-US" sz="2625" dirty="0"/>
           </a:p>
@@ -1961,7 +1735,7 @@
         </p:nvSpPr>
         <p:spPr>
           <a:xfrm>
-            <a:off x="666750" y="3008709"/>
+            <a:off x="666750" y="3683793"/>
             <a:ext cx="11163300" cy="1350169"/>
           </a:xfrm>
           <a:prstGeom prst="rect">
@@ -1974,21 +1748,21 @@
           <a:bodyPr wrap="square" lIns="0" tIns="0" rIns="0" bIns="0" rtlCol="0" anchor="t"/>
           <a:lstStyle/>
           <a:p>
-            <a:pPr algn="l" indent="0" marL="0">
+            <a:pPr marL="0" indent="0" algn="l">
               <a:lnSpc>
                 <a:spcPct val="135000"/>
               </a:lnSpc>
               <a:buNone/>
             </a:pPr>
             <a:r>
-              <a:rPr lang="en-US" sz="2625" u="sng" spc="94" kern="0" dirty="0">
+              <a:rPr lang="en-US" sz="2625" u="sng" kern="0" spc="94" dirty="0">
                 <a:solidFill>
                   <a:srgbClr val="0288D1"/>
                 </a:solidFill>
                 <a:latin typeface="Lato" pitchFamily="34" charset="0"/>
                 <a:ea typeface="Lato" pitchFamily="34" charset="-122"/>
                 <a:cs typeface="Lato" pitchFamily="34" charset="-120"/>
-                <a:hlinkClick r:id="rId2" invalidUrl="" action="" tgtFrame="" tooltip="" history="1" highlightClick="0" endSnd="0">
+                <a:hlinkClick r:id="rId4">
                   <a:extLst>
                     <a:ext uri="{A12FA001-AC4F-418D-AE19-62706E023703}">
                       <ahyp:hlinkClr xmlns:ahyp="http://schemas.microsoft.com/office/drawing/2018/hyperlinkcolor" val="tx"/>
@@ -1998,30 +1772,35 @@
               </a:rPr>
               <a:t>github.com/alvinashcraft</a:t>
             </a:r>
-            <a:pPr algn="l" indent="0" marL="0">
+            <a:r>
+              <a:rPr lang="en-US" sz="2625" u="sng" kern="0" spc="94" dirty="0">
+                <a:solidFill>
+                  <a:srgbClr val="0288D1"/>
+                </a:solidFill>
+                <a:latin typeface="Lato" pitchFamily="34" charset="0"/>
+                <a:ea typeface="Lato" pitchFamily="34" charset="-122"/>
+                <a:cs typeface="Lato" pitchFamily="34" charset="-120"/>
+              </a:rPr>
+              <a:t>/speaking</a:t>
+            </a:r>
+            <a:endParaRPr lang="en-US" sz="2625" dirty="0"/>
+          </a:p>
+          <a:p>
+            <a:pPr marL="0" indent="0" algn="l">
               <a:lnSpc>
                 <a:spcPct val="135000"/>
               </a:lnSpc>
               <a:buNone/>
             </a:pPr>
-            <a:endParaRPr lang="en-US" sz="2625" dirty="0"/>
-          </a:p>
-          <a:p>
-            <a:pPr algn="l" indent="0" marL="0">
-              <a:lnSpc>
-                <a:spcPct val="135000"/>
-              </a:lnSpc>
-              <a:buNone/>
-            </a:pPr>
-            <a:r>
-              <a:rPr lang="en-US" sz="2625" u="sng" spc="94" kern="0" dirty="0">
+            <a:r>
+              <a:rPr lang="en-US" sz="2625" u="sng" kern="0" spc="94" dirty="0">
                 <a:solidFill>
                   <a:srgbClr val="0288D1"/>
                 </a:solidFill>
                 <a:latin typeface="Lato" pitchFamily="34" charset="0"/>
                 <a:ea typeface="Lato" pitchFamily="34" charset="-122"/>
                 <a:cs typeface="Lato" pitchFamily="34" charset="-120"/>
-                <a:hlinkClick r:id="rId3" invalidUrl="" action="" tgtFrame="" tooltip="" history="1" highlightClick="0" endSnd="0">
+                <a:hlinkClick r:id="rId5">
                   <a:extLst>
                     <a:ext uri="{A12FA001-AC4F-418D-AE19-62706E023703}">
                       <ahyp:hlinkClr xmlns:ahyp="http://schemas.microsoft.com/office/drawing/2018/hyperlinkcolor" val="tx"/>
@@ -2031,30 +1810,24 @@
               </a:rPr>
               <a:t>alvinashcraft.com</a:t>
             </a:r>
-            <a:pPr algn="l" indent="0" marL="0">
+            <a:endParaRPr lang="en-US" sz="2625" dirty="0"/>
+          </a:p>
+          <a:p>
+            <a:pPr marL="0" indent="0" algn="l">
               <a:lnSpc>
                 <a:spcPct val="135000"/>
               </a:lnSpc>
               <a:buNone/>
             </a:pPr>
-            <a:endParaRPr lang="en-US" sz="2625" dirty="0"/>
-          </a:p>
-          <a:p>
-            <a:pPr algn="l" indent="0" marL="0">
-              <a:lnSpc>
-                <a:spcPct val="135000"/>
-              </a:lnSpc>
-              <a:buNone/>
-            </a:pPr>
-            <a:r>
-              <a:rPr lang="en-US" sz="2625" u="sng" spc="94" kern="0" dirty="0">
+            <a:r>
+              <a:rPr lang="en-US" sz="2625" u="sng" kern="0" spc="94" dirty="0">
                 <a:solidFill>
                   <a:srgbClr val="0288D1"/>
                 </a:solidFill>
                 <a:latin typeface="Lato" pitchFamily="34" charset="0"/>
                 <a:ea typeface="Lato" pitchFamily="34" charset="-122"/>
                 <a:cs typeface="Lato" pitchFamily="34" charset="-120"/>
-                <a:hlinkClick r:id="rId4" invalidUrl="" action="" tgtFrame="" tooltip="" history="1" highlightClick="0" endSnd="0">
+                <a:hlinkClick r:id="rId6">
                   <a:extLst>
                     <a:ext uri="{A12FA001-AC4F-418D-AE19-62706E023703}">
                       <ahyp:hlinkClr xmlns:ahyp="http://schemas.microsoft.com/office/drawing/2018/hyperlinkcolor" val="tx"/>
@@ -2089,14 +1862,14 @@
           <a:bodyPr wrap="square" lIns="0" tIns="0" rIns="0" bIns="0" rtlCol="0" anchor="t"/>
           <a:lstStyle/>
           <a:p>
-            <a:pPr algn="l" indent="0" marL="0">
+            <a:pPr marL="0" indent="0" algn="l">
               <a:lnSpc>
                 <a:spcPct val="238000"/>
               </a:lnSpc>
               <a:buNone/>
             </a:pPr>
             <a:r>
-              <a:rPr lang="en-US" sz="1575" spc="94" kern="0" dirty="0">
+              <a:rPr lang="en-US" sz="1575" kern="0" spc="94" dirty="0">
                 <a:solidFill>
                   <a:srgbClr val="6A7A7D"/>
                 </a:solidFill>
@@ -2130,7 +1903,7 @@
           </a:prstGeom>
           <a:extLst>
             <a:ext uri="{C572A759-6A51-4108-AA02-DFA0A04FC94B}">
-              <ma14:wrappingTextBoxFlag xmlns:ma14="http://schemas.microsoft.com/office/mac/drawingml/2011/main" val="0"/>
+              <ma14:wrappingTextBoxFlag xmlns:ma14="http://schemas.microsoft.com/office/mac/drawingml/2011/main" xmlns="" val="0"/>
             </a:ext>
           </a:extLst>
         </p:spPr>
@@ -2148,7 +1921,7 @@
           <a:p>
             <a:pPr algn="r"/>
             <a:fld id="{F7021451-1387-4CA6-816F-3879F97B5CBC}" type="slidenum">
-              <a:rPr b="0" lang="en-US"/>
+              <a:rPr lang="en-US" b="0"/>
               <a:t>2</a:t>
             </a:fld>
             <a:endParaRPr lang="en-US"/>
@@ -2169,7 +1942,7 @@
     <p:bg>
       <p:bgPr>
         <a:blipFill dpi="0" rotWithShape="1">
-          <a:blip r:embed="rId1">
+          <a:blip r:embed="rId3">
             <a:lum/>
           </a:blip>
           <a:srcRect/>
@@ -2215,14 +1988,14 @@
           <a:bodyPr wrap="square" lIns="0" tIns="0" rIns="0" bIns="0" rtlCol="0" anchor="t"/>
           <a:lstStyle/>
           <a:p>
-            <a:pPr algn="l" indent="0" marL="0">
+            <a:pPr marL="0" indent="0" algn="l">
               <a:lnSpc>
                 <a:spcPct val="216000"/>
               </a:lnSpc>
               <a:buNone/>
             </a:pPr>
             <a:r>
-              <a:rPr lang="en-US" sz="1733" b="1" spc="94" kern="0" dirty="0">
+              <a:rPr lang="en-US" sz="1733" b="1" kern="0" spc="94" dirty="0">
                 <a:solidFill>
                   <a:srgbClr val="6A7A7D"/>
                 </a:solidFill>
@@ -2257,14 +2030,14 @@
           <a:bodyPr wrap="square" lIns="0" tIns="0" rIns="0" bIns="0" rtlCol="0" anchor="t"/>
           <a:lstStyle/>
           <a:p>
-            <a:pPr algn="l" indent="0" marL="0">
+            <a:pPr marL="0" indent="0" algn="l">
               <a:lnSpc>
                 <a:spcPct val="135000"/>
               </a:lnSpc>
               <a:buNone/>
             </a:pPr>
             <a:r>
-              <a:rPr lang="en-US" sz="3938" b="1" spc="94" kern="0" dirty="0">
+              <a:rPr lang="en-US" sz="3938" b="1" kern="0" spc="94" dirty="0">
                 <a:solidFill>
                   <a:srgbClr val="455A64"/>
                 </a:solidFill>
@@ -2299,7 +2072,7 @@
           <a:bodyPr wrap="square" lIns="0" tIns="0" rIns="0" bIns="0" rtlCol="0" anchor="t"/>
           <a:lstStyle/>
           <a:p>
-            <a:pPr algn="l" marL="342900" indent="-342900">
+            <a:pPr marL="342900" indent="-342900" algn="l">
               <a:lnSpc>
                 <a:spcPct val="135000"/>
               </a:lnSpc>
@@ -2307,7 +2080,7 @@
               <a:buChar char="•"/>
             </a:pPr>
             <a:r>
-              <a:rPr lang="en-US" sz="2625" spc="94" kern="0" dirty="0">
+              <a:rPr lang="en-US" sz="2625" kern="0" spc="94" dirty="0">
                 <a:solidFill>
                   <a:srgbClr val="455A64"/>
                 </a:solidFill>
@@ -2320,7 +2093,7 @@
             <a:endParaRPr lang="en-US" sz="2625" dirty="0"/>
           </a:p>
           <a:p>
-            <a:pPr algn="l" marL="342900" indent="-342900">
+            <a:pPr marL="342900" indent="-342900" algn="l">
               <a:lnSpc>
                 <a:spcPct val="135000"/>
               </a:lnSpc>
@@ -2328,7 +2101,7 @@
               <a:buChar char="•"/>
             </a:pPr>
             <a:r>
-              <a:rPr lang="en-US" sz="2625" spc="94" kern="0" dirty="0">
+              <a:rPr lang="en-US" sz="2625" kern="0" spc="94" dirty="0">
                 <a:solidFill>
                   <a:srgbClr val="455A64"/>
                 </a:solidFill>
@@ -2341,7 +2114,7 @@
             <a:endParaRPr lang="en-US" sz="2625" dirty="0"/>
           </a:p>
           <a:p>
-            <a:pPr algn="l" marL="342900" indent="-342900">
+            <a:pPr marL="342900" indent="-342900" algn="l">
               <a:lnSpc>
                 <a:spcPct val="135000"/>
               </a:lnSpc>
@@ -2349,7 +2122,7 @@
               <a:buChar char="•"/>
             </a:pPr>
             <a:r>
-              <a:rPr lang="en-US" sz="2625" b="1" spc="94" kern="0" dirty="0">
+              <a:rPr lang="en-US" sz="2625" b="1" kern="0" spc="94" dirty="0">
                 <a:solidFill>
                   <a:srgbClr val="455A64"/>
                 </a:solidFill>
@@ -2359,14 +2132,8 @@
               </a:rPr>
               <a:t>Demos</a:t>
             </a:r>
-            <a:pPr algn="l" indent="0" marL="0">
-              <a:lnSpc>
-                <a:spcPct val="135000"/>
-              </a:lnSpc>
-              <a:buNone/>
-            </a:pPr>
-            <a:r>
-              <a:rPr lang="en-US" sz="2625" spc="94" kern="0" dirty="0">
+            <a:r>
+              <a:rPr lang="en-US" sz="2625" kern="0" spc="94" dirty="0">
                 <a:solidFill>
                   <a:srgbClr val="455A64"/>
                 </a:solidFill>
@@ -2401,14 +2168,14 @@
           <a:bodyPr wrap="square" lIns="0" tIns="0" rIns="0" bIns="0" rtlCol="0" anchor="t"/>
           <a:lstStyle/>
           <a:p>
-            <a:pPr algn="l" indent="0" marL="0">
+            <a:pPr marL="0" indent="0" algn="l">
               <a:lnSpc>
                 <a:spcPct val="238000"/>
               </a:lnSpc>
               <a:buNone/>
             </a:pPr>
             <a:r>
-              <a:rPr lang="en-US" sz="1575" spc="94" kern="0" dirty="0">
+              <a:rPr lang="en-US" sz="1575" kern="0" spc="94" dirty="0">
                 <a:solidFill>
                   <a:srgbClr val="6A7A7D"/>
                 </a:solidFill>
@@ -2442,7 +2209,7 @@
           </a:prstGeom>
           <a:extLst>
             <a:ext uri="{C572A759-6A51-4108-AA02-DFA0A04FC94B}">
-              <ma14:wrappingTextBoxFlag xmlns:ma14="http://schemas.microsoft.com/office/mac/drawingml/2011/main" val="0"/>
+              <ma14:wrappingTextBoxFlag xmlns:ma14="http://schemas.microsoft.com/office/mac/drawingml/2011/main" xmlns="" val="0"/>
             </a:ext>
           </a:extLst>
         </p:spPr>
@@ -2460,7 +2227,7 @@
           <a:p>
             <a:pPr algn="r"/>
             <a:fld id="{F7021451-1387-4CA6-816F-3879F97B5CBC}" type="slidenum">
-              <a:rPr b="0" lang="en-US"/>
+              <a:rPr lang="en-US" b="0"/>
               <a:t>3</a:t>
             </a:fld>
             <a:endParaRPr lang="en-US"/>
@@ -2483,6 +2250,7 @@
         <a:solidFill>
           <a:srgbClr val="FFFFFF"/>
         </a:solidFill>
+        <a:effectLst/>
       </p:bgPr>
     </p:bg>
     <p:spTree>
@@ -2501,14 +2269,14 @@
       </p:grpSpPr>
       <p:pic>
         <p:nvPicPr>
-          <p:cNvPr id="2" name="Image 0" descr="preencoded.png">    </p:cNvPr>
+          <p:cNvPr id="2" name="Image 0" descr="preencoded.png"/>
           <p:cNvPicPr>
             <a:picLocks noChangeAspect="1"/>
           </p:cNvPicPr>
           <p:nvPr/>
         </p:nvPicPr>
         <p:blipFill>
-          <a:blip r:embed="rId1"/>
+          <a:blip r:embed="rId3"/>
           <a:stretch>
             <a:fillRect/>
           </a:stretch>
@@ -2544,14 +2312,14 @@
           <a:bodyPr wrap="square" lIns="0" tIns="0" rIns="0" bIns="0" rtlCol="0" anchor="t"/>
           <a:lstStyle/>
           <a:p>
-            <a:pPr algn="l" indent="0" marL="0">
+            <a:pPr marL="0" indent="0" algn="l">
               <a:lnSpc>
                 <a:spcPct val="216000"/>
               </a:lnSpc>
               <a:buNone/>
             </a:pPr>
             <a:r>
-              <a:rPr lang="en-US" sz="1733" b="1" spc="94" kern="0" dirty="0">
+              <a:rPr lang="en-US" sz="1733" b="1" kern="0" spc="94" dirty="0">
                 <a:solidFill>
                   <a:srgbClr val="6A7A7D"/>
                 </a:solidFill>
@@ -2586,14 +2354,14 @@
           <a:bodyPr wrap="square" lIns="0" tIns="0" rIns="0" bIns="0" rtlCol="0" anchor="t"/>
           <a:lstStyle/>
           <a:p>
-            <a:pPr algn="l" indent="0" marL="0">
+            <a:pPr marL="0" indent="0" algn="l">
               <a:lnSpc>
                 <a:spcPct val="135000"/>
               </a:lnSpc>
               <a:buNone/>
             </a:pPr>
             <a:r>
-              <a:rPr lang="en-US" sz="3938" b="1" spc="94" kern="0" dirty="0">
+              <a:rPr lang="en-US" sz="3938" b="1" kern="0" spc="94" dirty="0">
                 <a:solidFill>
                   <a:srgbClr val="455A64"/>
                 </a:solidFill>
@@ -2615,8 +2383,8 @@
         </p:nvSpPr>
         <p:spPr>
           <a:xfrm>
-            <a:off x="666750" y="1675209"/>
-            <a:ext cx="6591300" cy="3550444"/>
+            <a:off x="666750" y="1675208"/>
+            <a:ext cx="6591300" cy="4323515"/>
           </a:xfrm>
           <a:prstGeom prst="rect">
             <a:avLst/>
@@ -2628,7 +2396,7 @@
           <a:bodyPr wrap="square" lIns="0" tIns="0" rIns="0" bIns="0" rtlCol="0" anchor="t"/>
           <a:lstStyle/>
           <a:p>
-            <a:pPr algn="l" marL="342900" indent="-342900">
+            <a:pPr marL="342900" indent="-342900" algn="l">
               <a:lnSpc>
                 <a:spcPct val="135000"/>
               </a:lnSpc>
@@ -2636,7 +2404,7 @@
               <a:buChar char="•"/>
             </a:pPr>
             <a:r>
-              <a:rPr lang="en-US" sz="2625" b="1" spc="94" kern="0" dirty="0">
+              <a:rPr lang="en-US" sz="2400" b="1" kern="0" spc="94" dirty="0">
                 <a:solidFill>
                   <a:srgbClr val="455A64"/>
                 </a:solidFill>
@@ -2646,14 +2414,8 @@
               </a:rPr>
               <a:t>Open-source</a:t>
             </a:r>
-            <a:pPr algn="l" indent="0" marL="0">
-              <a:lnSpc>
-                <a:spcPct val="135000"/>
-              </a:lnSpc>
-              <a:buNone/>
-            </a:pPr>
-            <a:r>
-              <a:rPr lang="en-US" sz="2625" spc="94" kern="0" dirty="0">
+            <a:r>
+              <a:rPr lang="en-US" sz="2400" kern="0" spc="94" dirty="0">
                 <a:solidFill>
                   <a:srgbClr val="455A64"/>
                 </a:solidFill>
@@ -2663,10 +2425,9 @@
               </a:rPr>
               <a:t> Windows app from Microsoft</a:t>
             </a:r>
-            <a:endParaRPr lang="en-US" sz="2625" dirty="0"/>
-          </a:p>
-          <a:p>
-            <a:pPr algn="l" marL="342900" indent="-342900">
+          </a:p>
+          <a:p>
+            <a:pPr marL="342900" indent="-342900" algn="l">
               <a:lnSpc>
                 <a:spcPct val="135000"/>
               </a:lnSpc>
@@ -2674,37 +2435,20 @@
               <a:buChar char="•"/>
             </a:pPr>
             <a:r>
-              <a:rPr lang="en-US" sz="2625" spc="94" kern="0" dirty="0">
-                <a:solidFill>
-                  <a:srgbClr val="455A64"/>
-                </a:solidFill>
-                <a:latin typeface="Lato" pitchFamily="34" charset="0"/>
-                <a:ea typeface="Lato" pitchFamily="34" charset="-122"/>
-                <a:cs typeface="Lato" pitchFamily="34" charset="-120"/>
-              </a:rPr>
-              <a:t>Available free in the </a:t>
-            </a:r>
-            <a:pPr algn="l" indent="0" marL="0">
-              <a:lnSpc>
-                <a:spcPct val="135000"/>
-              </a:lnSpc>
-              <a:buNone/>
-            </a:pPr>
-            <a:r>
-              <a:rPr lang="en-US" sz="2625" b="1" spc="94" kern="0" dirty="0">
-                <a:solidFill>
-                  <a:srgbClr val="455A64"/>
-                </a:solidFill>
-                <a:latin typeface="Lato" pitchFamily="34" charset="0"/>
-                <a:ea typeface="Lato" pitchFamily="34" charset="-122"/>
-                <a:cs typeface="Lato" pitchFamily="34" charset="-120"/>
-              </a:rPr>
-              <a:t>Microsoft Store</a:t>
-            </a:r>
-            <a:endParaRPr lang="en-US" sz="2625" dirty="0"/>
-          </a:p>
-          <a:p>
-            <a:pPr algn="l" marL="342900" indent="-342900">
+              <a:rPr lang="en-US" sz="2400" kern="0" spc="94" dirty="0">
+                <a:solidFill>
+                  <a:srgbClr val="455A64"/>
+                </a:solidFill>
+                <a:latin typeface="Lato" pitchFamily="34" charset="0"/>
+                <a:ea typeface="Lato" pitchFamily="34" charset="-122"/>
+                <a:cs typeface="Lato" pitchFamily="34" charset="-120"/>
+              </a:rPr>
+              <a:t>Build and run from GitHub source</a:t>
+            </a:r>
+            <a:endParaRPr lang="en-US" sz="2400" dirty="0"/>
+          </a:p>
+          <a:p>
+            <a:pPr marL="342900" indent="-342900" algn="l">
               <a:lnSpc>
                 <a:spcPct val="135000"/>
               </a:lnSpc>
@@ -2712,54 +2456,31 @@
               <a:buChar char="•"/>
             </a:pPr>
             <a:r>
-              <a:rPr lang="en-US" sz="2625" spc="94" kern="0" dirty="0">
-                <a:solidFill>
-                  <a:srgbClr val="455A64"/>
-                </a:solidFill>
-                <a:latin typeface="Lato" pitchFamily="34" charset="0"/>
-                <a:ea typeface="Lato" pitchFamily="34" charset="-122"/>
-                <a:cs typeface="Lato" pitchFamily="34" charset="-120"/>
-              </a:rPr>
-              <a:t>Integrate </a:t>
-            </a:r>
-            <a:pPr algn="l" indent="0" marL="0">
-              <a:lnSpc>
-                <a:spcPct val="135000"/>
-              </a:lnSpc>
-              <a:buNone/>
-            </a:pPr>
-            <a:r>
-              <a:rPr lang="en-US" sz="2625" b="1" spc="94" kern="0" dirty="0">
-                <a:solidFill>
-                  <a:srgbClr val="455A64"/>
-                </a:solidFill>
-                <a:latin typeface="Lato" pitchFamily="34" charset="0"/>
-                <a:ea typeface="Lato" pitchFamily="34" charset="-122"/>
-                <a:cs typeface="Lato" pitchFamily="34" charset="-120"/>
-              </a:rPr>
-              <a:t>AI capabilities</a:t>
-            </a:r>
-            <a:pPr algn="l" indent="0" marL="0">
-              <a:lnSpc>
-                <a:spcPct val="135000"/>
-              </a:lnSpc>
-              <a:buNone/>
-            </a:pPr>
-            <a:r>
-              <a:rPr lang="en-US" sz="2625" spc="94" kern="0" dirty="0">
-                <a:solidFill>
-                  <a:srgbClr val="455A64"/>
-                </a:solidFill>
-                <a:latin typeface="Lato" pitchFamily="34" charset="0"/>
-                <a:ea typeface="Lato" pitchFamily="34" charset="-122"/>
-                <a:cs typeface="Lato" pitchFamily="34" charset="-120"/>
-              </a:rPr>
-              <a:t> into your native Windows apps</a:t>
-            </a:r>
-            <a:endParaRPr lang="en-US" sz="2625" dirty="0"/>
-          </a:p>
-          <a:p>
-            <a:pPr algn="l" marL="342900" indent="-342900">
+              <a:rPr lang="en-US" sz="2400" kern="0" spc="94" dirty="0">
+                <a:solidFill>
+                  <a:srgbClr val="455A64"/>
+                </a:solidFill>
+                <a:latin typeface="Lato" pitchFamily="34" charset="0"/>
+                <a:ea typeface="Lato" pitchFamily="34" charset="-122"/>
+                <a:cs typeface="Lato" pitchFamily="34" charset="-120"/>
+              </a:rPr>
+              <a:t>Available free in the </a:t>
+            </a:r>
+            <a:r>
+              <a:rPr lang="en-US" sz="2400" b="1" kern="0" spc="94" dirty="0">
+                <a:solidFill>
+                  <a:srgbClr val="455A64"/>
+                </a:solidFill>
+                <a:latin typeface="Lato" pitchFamily="34" charset="0"/>
+                <a:ea typeface="Lato" pitchFamily="34" charset="-122"/>
+                <a:cs typeface="Lato" pitchFamily="34" charset="-120"/>
+              </a:rPr>
+              <a:t>Microsoft Store</a:t>
+            </a:r>
+            <a:endParaRPr lang="en-US" sz="2400" dirty="0"/>
+          </a:p>
+          <a:p>
+            <a:pPr marL="342900" indent="-342900" algn="l">
               <a:lnSpc>
                 <a:spcPct val="135000"/>
               </a:lnSpc>
@@ -2767,20 +2488,42 @@
               <a:buChar char="•"/>
             </a:pPr>
             <a:r>
-              <a:rPr lang="en-US" sz="2625" spc="94" kern="0" dirty="0">
-                <a:solidFill>
-                  <a:srgbClr val="455A64"/>
-                </a:solidFill>
-                <a:latin typeface="Lato" pitchFamily="34" charset="0"/>
-                <a:ea typeface="Lato" pitchFamily="34" charset="-122"/>
-                <a:cs typeface="Lato" pitchFamily="34" charset="-120"/>
-              </a:rPr>
-              <a:t>Discover AI scenarios &amp; models</a:t>
-            </a:r>
-            <a:endParaRPr lang="en-US" sz="2625" dirty="0"/>
-          </a:p>
-          <a:p>
-            <a:pPr algn="l" marL="342900" indent="-342900">
+              <a:rPr lang="en-US" sz="2400" kern="0" spc="94" dirty="0">
+                <a:solidFill>
+                  <a:srgbClr val="455A64"/>
+                </a:solidFill>
+                <a:latin typeface="Lato" pitchFamily="34" charset="0"/>
+                <a:ea typeface="Lato" pitchFamily="34" charset="-122"/>
+                <a:cs typeface="Lato" pitchFamily="34" charset="-120"/>
+              </a:rPr>
+              <a:t>Integrate </a:t>
+            </a:r>
+            <a:r>
+              <a:rPr lang="en-US" sz="2400" b="1" kern="0" spc="94" dirty="0">
+                <a:solidFill>
+                  <a:srgbClr val="455A64"/>
+                </a:solidFill>
+                <a:latin typeface="Lato" pitchFamily="34" charset="0"/>
+                <a:ea typeface="Lato" pitchFamily="34" charset="-122"/>
+                <a:cs typeface="Lato" pitchFamily="34" charset="-120"/>
+              </a:rPr>
+              <a:t>AI capabilities</a:t>
+            </a:r>
+            <a:r>
+              <a:rPr lang="en-US" sz="2400" kern="0" spc="94" dirty="0">
+                <a:solidFill>
+                  <a:srgbClr val="455A64"/>
+                </a:solidFill>
+                <a:latin typeface="Lato" pitchFamily="34" charset="0"/>
+                <a:ea typeface="Lato" pitchFamily="34" charset="-122"/>
+                <a:cs typeface="Lato" pitchFamily="34" charset="-120"/>
+              </a:rPr>
+              <a:t> into your native Windows apps</a:t>
+            </a:r>
+            <a:endParaRPr lang="en-US" sz="2400" dirty="0"/>
+          </a:p>
+          <a:p>
+            <a:pPr marL="342900" indent="-342900" algn="l">
               <a:lnSpc>
                 <a:spcPct val="135000"/>
               </a:lnSpc>
@@ -2788,7 +2531,28 @@
               <a:buChar char="•"/>
             </a:pPr>
             <a:r>
-              <a:rPr lang="en-US" sz="2625" spc="94" kern="0" dirty="0">
+              <a:rPr lang="en-US" sz="2400" kern="0" spc="94" dirty="0">
+                <a:solidFill>
+                  <a:srgbClr val="455A64"/>
+                </a:solidFill>
+                <a:latin typeface="Lato" pitchFamily="34" charset="0"/>
+                <a:ea typeface="Lato" pitchFamily="34" charset="-122"/>
+                <a:cs typeface="Lato" pitchFamily="34" charset="-120"/>
+              </a:rPr>
+              <a:t>Discover AI scenarios, projects, &amp; models</a:t>
+            </a:r>
+            <a:endParaRPr lang="en-US" sz="2400" dirty="0"/>
+          </a:p>
+          <a:p>
+            <a:pPr marL="342900" indent="-342900" algn="l">
+              <a:lnSpc>
+                <a:spcPct val="135000"/>
+              </a:lnSpc>
+              <a:buSzPct val="100000"/>
+              <a:buChar char="•"/>
+            </a:pPr>
+            <a:r>
+              <a:rPr lang="en-US" sz="2400" kern="0" spc="94" dirty="0">
                 <a:solidFill>
                   <a:srgbClr val="455A64"/>
                 </a:solidFill>
@@ -2798,14 +2562,8 @@
               </a:rPr>
               <a:t>Built with </a:t>
             </a:r>
-            <a:pPr algn="l" indent="0" marL="0">
-              <a:lnSpc>
-                <a:spcPct val="135000"/>
-              </a:lnSpc>
-              <a:buNone/>
-            </a:pPr>
-            <a:r>
-              <a:rPr lang="en-US" sz="2625" b="1" spc="94" kern="0" dirty="0">
+            <a:r>
+              <a:rPr lang="en-US" sz="2400" b="1" kern="0" spc="94" dirty="0">
                 <a:solidFill>
                   <a:srgbClr val="455A64"/>
                 </a:solidFill>
@@ -2815,14 +2573,8 @@
               </a:rPr>
               <a:t>WinUI</a:t>
             </a:r>
-            <a:pPr algn="l" indent="0" marL="0">
-              <a:lnSpc>
-                <a:spcPct val="135000"/>
-              </a:lnSpc>
-              <a:buNone/>
-            </a:pPr>
-            <a:r>
-              <a:rPr lang="en-US" sz="2625" spc="94" kern="0" dirty="0">
+            <a:r>
+              <a:rPr lang="en-US" sz="2400" kern="0" spc="94" dirty="0">
                 <a:solidFill>
                   <a:srgbClr val="455A64"/>
                 </a:solidFill>
@@ -2832,14 +2584,8 @@
               </a:rPr>
               <a:t> &amp; </a:t>
             </a:r>
-            <a:pPr algn="l" indent="0" marL="0">
-              <a:lnSpc>
-                <a:spcPct val="135000"/>
-              </a:lnSpc>
-              <a:buNone/>
-            </a:pPr>
-            <a:r>
-              <a:rPr lang="en-US" sz="2625" b="1" spc="94" kern="0" dirty="0">
+            <a:r>
+              <a:rPr lang="en-US" sz="2400" b="1" kern="0" spc="94" dirty="0">
                 <a:solidFill>
                   <a:srgbClr val="455A64"/>
                 </a:solidFill>
@@ -2849,7 +2595,7 @@
               </a:rPr>
               <a:t>Windows App SDK</a:t>
             </a:r>
-            <a:endParaRPr lang="en-US" sz="2625" dirty="0"/>
+            <a:endParaRPr lang="en-US" sz="2400" dirty="0"/>
           </a:p>
         </p:txBody>
       </p:sp>
@@ -2874,14 +2620,14 @@
           <a:bodyPr wrap="square" lIns="0" tIns="0" rIns="0" bIns="0" rtlCol="0" anchor="t"/>
           <a:lstStyle/>
           <a:p>
-            <a:pPr algn="l" indent="0" marL="0">
+            <a:pPr marL="0" indent="0" algn="l">
               <a:lnSpc>
                 <a:spcPct val="238000"/>
               </a:lnSpc>
               <a:buNone/>
             </a:pPr>
             <a:r>
-              <a:rPr lang="en-US" sz="1575" spc="94" kern="0" dirty="0">
+              <a:rPr lang="en-US" sz="1575" kern="0" spc="94" dirty="0">
                 <a:solidFill>
                   <a:srgbClr val="6A7A7D"/>
                 </a:solidFill>
@@ -2915,7 +2661,7 @@
           </a:prstGeom>
           <a:extLst>
             <a:ext uri="{C572A759-6A51-4108-AA02-DFA0A04FC94B}">
-              <ma14:wrappingTextBoxFlag xmlns:ma14="http://schemas.microsoft.com/office/mac/drawingml/2011/main" val="0"/>
+              <ma14:wrappingTextBoxFlag xmlns:ma14="http://schemas.microsoft.com/office/mac/drawingml/2011/main" xmlns="" val="0"/>
             </a:ext>
           </a:extLst>
         </p:spPr>
@@ -2933,7 +2679,7 @@
           <a:p>
             <a:pPr algn="r"/>
             <a:fld id="{F7021451-1387-4CA6-816F-3879F97B5CBC}" type="slidenum">
-              <a:rPr b="0" lang="en-US"/>
+              <a:rPr lang="en-US" b="0"/>
               <a:t>4</a:t>
             </a:fld>
             <a:endParaRPr lang="en-US"/>
@@ -2954,7 +2700,7 @@
     <p:bg>
       <p:bgPr>
         <a:blipFill dpi="0" rotWithShape="1">
-          <a:blip r:embed="rId1">
+          <a:blip r:embed="rId3">
             <a:lum/>
           </a:blip>
           <a:srcRect/>
@@ -3000,14 +2746,14 @@
           <a:bodyPr wrap="square" lIns="0" tIns="0" rIns="0" bIns="0" rtlCol="0" anchor="t"/>
           <a:lstStyle/>
           <a:p>
-            <a:pPr algn="l" indent="0" marL="0">
+            <a:pPr marL="0" indent="0" algn="l">
               <a:lnSpc>
                 <a:spcPct val="216000"/>
               </a:lnSpc>
               <a:buNone/>
             </a:pPr>
             <a:r>
-              <a:rPr lang="en-US" sz="1733" b="1" spc="94" kern="0" dirty="0">
+              <a:rPr lang="en-US" sz="1733" b="1" kern="0" spc="94" dirty="0">
                 <a:solidFill>
                   <a:srgbClr val="6A7A7D"/>
                 </a:solidFill>
@@ -3042,14 +2788,14 @@
           <a:bodyPr wrap="square" lIns="0" tIns="0" rIns="0" bIns="0" rtlCol="0" anchor="t"/>
           <a:lstStyle/>
           <a:p>
-            <a:pPr algn="l" indent="0" marL="0">
+            <a:pPr marL="0" indent="0" algn="l">
               <a:lnSpc>
                 <a:spcPct val="135000"/>
               </a:lnSpc>
               <a:buNone/>
             </a:pPr>
             <a:r>
-              <a:rPr lang="en-US" sz="3938" b="1" spc="94" kern="0" dirty="0">
+              <a:rPr lang="en-US" sz="3938" b="1" kern="0" spc="94" dirty="0">
                 <a:solidFill>
                   <a:srgbClr val="455A64"/>
                 </a:solidFill>
@@ -3084,39 +2830,22 @@
           <a:bodyPr wrap="square" lIns="0" tIns="0" rIns="0" bIns="0" rtlCol="0" anchor="t"/>
           <a:lstStyle/>
           <a:p>
-            <a:pPr algn="l" indent="0" marL="0">
+            <a:pPr marL="0" indent="0" algn="l">
               <a:lnSpc>
                 <a:spcPct val="135000"/>
               </a:lnSpc>
               <a:buNone/>
             </a:pPr>
             <a:r>
-              <a:rPr lang="en-US" sz="3413" b="1" spc="94" kern="0" dirty="0">
-                <a:solidFill>
-                  <a:srgbClr val="455A64"/>
-                </a:solidFill>
-                <a:latin typeface="Lato" pitchFamily="34" charset="0"/>
-                <a:ea typeface="Lato" pitchFamily="34" charset="-122"/>
-                <a:cs typeface="Lato" pitchFamily="34" charset="-120"/>
-              </a:rPr>
-              <a:t>🧠</a:t>
-            </a:r>
-            <a:pPr algn="l" indent="0" marL="0">
-              <a:lnSpc>
-                <a:spcPct val="135000"/>
-              </a:lnSpc>
-              <a:buNone/>
-            </a:pPr>
-            <a:r>
-              <a:rPr lang="en-US" sz="3413" b="1" spc="94" kern="0" dirty="0">
-                <a:solidFill>
-                  <a:srgbClr val="455A64"/>
-                </a:solidFill>
-                <a:latin typeface="Lato" pitchFamily="34" charset="0"/>
-                <a:ea typeface="Lato" pitchFamily="34" charset="-122"/>
-                <a:cs typeface="Lato" pitchFamily="34" charset="-120"/>
-              </a:rPr>
-              <a:t> Models &amp; Samples</a:t>
+              <a:rPr lang="en-US" sz="3413" b="1" kern="0" spc="94" dirty="0">
+                <a:solidFill>
+                  <a:srgbClr val="455A64"/>
+                </a:solidFill>
+                <a:latin typeface="Lato" pitchFamily="34" charset="0"/>
+                <a:ea typeface="Lato" pitchFamily="34" charset="-122"/>
+                <a:cs typeface="Lato" pitchFamily="34" charset="-120"/>
+              </a:rPr>
+              <a:t>🧠 Models &amp; Samples</a:t>
             </a:r>
             <a:endParaRPr lang="en-US" sz="3413" dirty="0"/>
           </a:p>
@@ -3143,7 +2872,7 @@
           <a:bodyPr wrap="square" lIns="0" tIns="0" rIns="0" bIns="0" rtlCol="0" anchor="t"/>
           <a:lstStyle/>
           <a:p>
-            <a:pPr algn="l" marL="342900" indent="-342900">
+            <a:pPr marL="342900" indent="-342900" algn="l">
               <a:lnSpc>
                 <a:spcPct val="135000"/>
               </a:lnSpc>
@@ -3151,7 +2880,7 @@
               <a:buChar char="•"/>
             </a:pPr>
             <a:r>
-              <a:rPr lang="en-US" sz="2625" b="1" spc="94" kern="0" dirty="0">
+              <a:rPr lang="en-US" sz="2625" b="1" kern="0" spc="94" dirty="0">
                 <a:solidFill>
                   <a:srgbClr val="455A64"/>
                 </a:solidFill>
@@ -3161,14 +2890,8 @@
               </a:rPr>
               <a:t>25+ interactive samples</a:t>
             </a:r>
-            <a:pPr algn="l" indent="0" marL="0">
-              <a:lnSpc>
-                <a:spcPct val="135000"/>
-              </a:lnSpc>
-              <a:buNone/>
-            </a:pPr>
-            <a:r>
-              <a:rPr lang="en-US" sz="2625" spc="94" kern="0" dirty="0">
+            <a:r>
+              <a:rPr lang="en-US" sz="2625" kern="0" spc="94" dirty="0">
                 <a:solidFill>
                   <a:srgbClr val="455A64"/>
                 </a:solidFill>
@@ -3181,7 +2904,7 @@
             <a:endParaRPr lang="en-US" sz="2625" dirty="0"/>
           </a:p>
           <a:p>
-            <a:pPr algn="l" marL="342900" indent="-342900">
+            <a:pPr marL="342900" indent="-342900" algn="l">
               <a:lnSpc>
                 <a:spcPct val="135000"/>
               </a:lnSpc>
@@ -3189,7 +2912,7 @@
               <a:buChar char="•"/>
             </a:pPr>
             <a:r>
-              <a:rPr lang="en-US" sz="2625" spc="94" kern="0" dirty="0">
+              <a:rPr lang="en-US" sz="2625" kern="0" spc="94" dirty="0">
                 <a:solidFill>
                   <a:srgbClr val="455A64"/>
                 </a:solidFill>
@@ -3199,14 +2922,8 @@
               </a:rPr>
               <a:t>Browse and download models from </a:t>
             </a:r>
-            <a:pPr algn="l" indent="0" marL="0">
-              <a:lnSpc>
-                <a:spcPct val="135000"/>
-              </a:lnSpc>
-              <a:buNone/>
-            </a:pPr>
-            <a:r>
-              <a:rPr lang="en-US" sz="2625" b="1" spc="94" kern="0" dirty="0">
+            <a:r>
+              <a:rPr lang="en-US" sz="2625" b="1" kern="0" spc="94" dirty="0">
                 <a:solidFill>
                   <a:srgbClr val="455A64"/>
                 </a:solidFill>
@@ -3216,14 +2933,8 @@
               </a:rPr>
               <a:t>Hugging Face</a:t>
             </a:r>
-            <a:pPr algn="l" indent="0" marL="0">
-              <a:lnSpc>
-                <a:spcPct val="135000"/>
-              </a:lnSpc>
-              <a:buNone/>
-            </a:pPr>
-            <a:r>
-              <a:rPr lang="en-US" sz="2625" spc="94" kern="0" dirty="0">
+            <a:r>
+              <a:rPr lang="en-US" sz="2625" kern="0" spc="94" dirty="0">
                 <a:solidFill>
                   <a:srgbClr val="455A64"/>
                 </a:solidFill>
@@ -3233,14 +2944,8 @@
               </a:rPr>
               <a:t> and </a:t>
             </a:r>
-            <a:pPr algn="l" indent="0" marL="0">
-              <a:lnSpc>
-                <a:spcPct val="135000"/>
-              </a:lnSpc>
-              <a:buNone/>
-            </a:pPr>
-            <a:r>
-              <a:rPr lang="en-US" sz="2625" b="1" spc="94" kern="0" dirty="0">
+            <a:r>
+              <a:rPr lang="en-US" sz="2625" b="1" kern="0" spc="94" dirty="0">
                 <a:solidFill>
                   <a:srgbClr val="455A64"/>
                 </a:solidFill>
@@ -3253,7 +2958,7 @@
             <a:endParaRPr lang="en-US" sz="2625" dirty="0"/>
           </a:p>
           <a:p>
-            <a:pPr algn="l" marL="342900" indent="-342900">
+            <a:pPr marL="342900" indent="-342900" algn="l">
               <a:lnSpc>
                 <a:spcPct val="135000"/>
               </a:lnSpc>
@@ -3261,7 +2966,7 @@
               <a:buChar char="•"/>
             </a:pPr>
             <a:r>
-              <a:rPr lang="en-US" sz="2625" spc="94" kern="0" dirty="0">
+              <a:rPr lang="en-US" sz="2625" kern="0" spc="94" dirty="0">
                 <a:solidFill>
                   <a:srgbClr val="455A64"/>
                 </a:solidFill>
@@ -3271,14 +2976,8 @@
               </a:rPr>
               <a:t>Supports </a:t>
             </a:r>
-            <a:pPr algn="l" indent="0" marL="0">
-              <a:lnSpc>
-                <a:spcPct val="135000"/>
-              </a:lnSpc>
-              <a:buNone/>
-            </a:pPr>
-            <a:r>
-              <a:rPr lang="en-US" sz="2625" b="1" spc="94" kern="0" dirty="0">
+            <a:r>
+              <a:rPr lang="en-US" sz="2625" b="1" kern="0" spc="94" dirty="0">
                 <a:solidFill>
                   <a:srgbClr val="455A64"/>
                 </a:solidFill>
@@ -3288,14 +2987,8 @@
               </a:rPr>
               <a:t>Phi Silica</a:t>
             </a:r>
-            <a:pPr algn="l" indent="0" marL="0">
-              <a:lnSpc>
-                <a:spcPct val="135000"/>
-              </a:lnSpc>
-              <a:buNone/>
-            </a:pPr>
-            <a:r>
-              <a:rPr lang="en-US" sz="2625" spc="94" kern="0" dirty="0">
+            <a:r>
+              <a:rPr lang="en-US" sz="2625" kern="0" spc="94" dirty="0">
                 <a:solidFill>
                   <a:srgbClr val="455A64"/>
                 </a:solidFill>
@@ -3330,39 +3023,22 @@
           <a:bodyPr wrap="square" lIns="0" tIns="0" rIns="0" bIns="0" rtlCol="0" anchor="t"/>
           <a:lstStyle/>
           <a:p>
-            <a:pPr algn="l" indent="0" marL="0">
+            <a:pPr marL="0" indent="0" algn="l">
               <a:lnSpc>
                 <a:spcPct val="135000"/>
               </a:lnSpc>
               <a:buNone/>
             </a:pPr>
             <a:r>
-              <a:rPr lang="en-US" sz="3413" b="1" spc="94" kern="0" dirty="0">
-                <a:solidFill>
-                  <a:srgbClr val="455A64"/>
-                </a:solidFill>
-                <a:latin typeface="Lato" pitchFamily="34" charset="0"/>
-                <a:ea typeface="Lato" pitchFamily="34" charset="-122"/>
-                <a:cs typeface="Lato" pitchFamily="34" charset="-120"/>
-              </a:rPr>
-              <a:t>🛠️</a:t>
-            </a:r>
-            <a:pPr algn="l" indent="0" marL="0">
-              <a:lnSpc>
-                <a:spcPct val="135000"/>
-              </a:lnSpc>
-              <a:buNone/>
-            </a:pPr>
-            <a:r>
-              <a:rPr lang="en-US" sz="3413" b="1" spc="94" kern="0" dirty="0">
-                <a:solidFill>
-                  <a:srgbClr val="455A64"/>
-                </a:solidFill>
-                <a:latin typeface="Lato" pitchFamily="34" charset="0"/>
-                <a:ea typeface="Lato" pitchFamily="34" charset="-122"/>
-                <a:cs typeface="Lato" pitchFamily="34" charset="-120"/>
-              </a:rPr>
-              <a:t> Developer Experience</a:t>
+              <a:rPr lang="en-US" sz="3413" b="1" kern="0" spc="94" dirty="0">
+                <a:solidFill>
+                  <a:srgbClr val="455A64"/>
+                </a:solidFill>
+                <a:latin typeface="Lato" pitchFamily="34" charset="0"/>
+                <a:ea typeface="Lato" pitchFamily="34" charset="-122"/>
+                <a:cs typeface="Lato" pitchFamily="34" charset="-120"/>
+              </a:rPr>
+              <a:t>🛠️ Developer Experience</a:t>
             </a:r>
             <a:endParaRPr lang="en-US" sz="3413" dirty="0"/>
           </a:p>
@@ -3389,7 +3065,7 @@
           <a:bodyPr wrap="square" lIns="0" tIns="0" rIns="0" bIns="0" rtlCol="0" anchor="t"/>
           <a:lstStyle/>
           <a:p>
-            <a:pPr algn="l" marL="342900" indent="-342900">
+            <a:pPr marL="342900" indent="-342900" algn="l">
               <a:lnSpc>
                 <a:spcPct val="135000"/>
               </a:lnSpc>
@@ -3397,7 +3073,7 @@
               <a:buChar char="•"/>
             </a:pPr>
             <a:r>
-              <a:rPr lang="en-US" sz="2625" spc="94" kern="0" dirty="0">
+              <a:rPr lang="en-US" sz="2625" kern="0" spc="94" dirty="0">
                 <a:solidFill>
                   <a:srgbClr val="455A64"/>
                 </a:solidFill>
@@ -3407,14 +3083,8 @@
               </a:rPr>
               <a:t>View </a:t>
             </a:r>
-            <a:pPr algn="l" indent="0" marL="0">
-              <a:lnSpc>
-                <a:spcPct val="135000"/>
-              </a:lnSpc>
-              <a:buNone/>
-            </a:pPr>
-            <a:r>
-              <a:rPr lang="en-US" sz="2625" b="1" spc="94" kern="0" dirty="0">
+            <a:r>
+              <a:rPr lang="en-US" sz="2625" b="1" kern="0" spc="94" dirty="0">
                 <a:solidFill>
                   <a:srgbClr val="455A64"/>
                 </a:solidFill>
@@ -3424,14 +3094,8 @@
               </a:rPr>
               <a:t>C# source code</a:t>
             </a:r>
-            <a:pPr algn="l" indent="0" marL="0">
-              <a:lnSpc>
-                <a:spcPct val="135000"/>
-              </a:lnSpc>
-              <a:buNone/>
-            </a:pPr>
-            <a:r>
-              <a:rPr lang="en-US" sz="2625" spc="94" kern="0" dirty="0">
+            <a:r>
+              <a:rPr lang="en-US" sz="2625" kern="0" spc="94" dirty="0">
                 <a:solidFill>
                   <a:srgbClr val="455A64"/>
                 </a:solidFill>
@@ -3444,7 +3108,7 @@
             <a:endParaRPr lang="en-US" sz="2625" dirty="0"/>
           </a:p>
           <a:p>
-            <a:pPr algn="l" marL="342900" indent="-342900">
+            <a:pPr marL="342900" indent="-342900" algn="l">
               <a:lnSpc>
                 <a:spcPct val="135000"/>
               </a:lnSpc>
@@ -3452,7 +3116,7 @@
               <a:buChar char="•"/>
             </a:pPr>
             <a:r>
-              <a:rPr lang="en-US" sz="2625" b="1" spc="94" kern="0" dirty="0">
+              <a:rPr lang="en-US" sz="2625" b="1" kern="0" spc="94" dirty="0">
                 <a:solidFill>
                   <a:srgbClr val="455A64"/>
                 </a:solidFill>
@@ -3462,14 +3126,8 @@
               </a:rPr>
               <a:t>Export standalone Visual Studio projects</a:t>
             </a:r>
-            <a:pPr algn="l" indent="0" marL="0">
-              <a:lnSpc>
-                <a:spcPct val="135000"/>
-              </a:lnSpc>
-              <a:buNone/>
-            </a:pPr>
-            <a:r>
-              <a:rPr lang="en-US" sz="2625" spc="94" kern="0" dirty="0">
+            <a:r>
+              <a:rPr lang="en-US" sz="2625" kern="0" spc="94" dirty="0">
                 <a:solidFill>
                   <a:srgbClr val="455A64"/>
                 </a:solidFill>
@@ -3482,7 +3140,7 @@
             <a:endParaRPr lang="en-US" sz="2625" dirty="0"/>
           </a:p>
           <a:p>
-            <a:pPr algn="l" marL="342900" indent="-342900">
+            <a:pPr marL="342900" indent="-342900" algn="l">
               <a:lnSpc>
                 <a:spcPct val="135000"/>
               </a:lnSpc>
@@ -3490,7 +3148,7 @@
               <a:buChar char="•"/>
             </a:pPr>
             <a:r>
-              <a:rPr lang="en-US" sz="2625" spc="94" kern="0" dirty="0">
+              <a:rPr lang="en-US" sz="2625" kern="0" spc="94" dirty="0">
                 <a:solidFill>
                   <a:srgbClr val="455A64"/>
                 </a:solidFill>
@@ -3500,14 +3158,8 @@
               </a:rPr>
               <a:t>Works </a:t>
             </a:r>
-            <a:pPr algn="l" indent="0" marL="0">
-              <a:lnSpc>
-                <a:spcPct val="135000"/>
-              </a:lnSpc>
-              <a:buNone/>
-            </a:pPr>
-            <a:r>
-              <a:rPr lang="en-US" sz="2625" b="1" spc="94" kern="0" dirty="0">
+            <a:r>
+              <a:rPr lang="en-US" sz="2625" b="1" kern="0" spc="94" dirty="0">
                 <a:solidFill>
                   <a:srgbClr val="455A64"/>
                 </a:solidFill>
@@ -3517,14 +3169,8 @@
               </a:rPr>
               <a:t>offline</a:t>
             </a:r>
-            <a:pPr algn="l" indent="0" marL="0">
-              <a:lnSpc>
-                <a:spcPct val="135000"/>
-              </a:lnSpc>
-              <a:buNone/>
-            </a:pPr>
-            <a:r>
-              <a:rPr lang="en-US" sz="2625" spc="94" kern="0" dirty="0">
+            <a:r>
+              <a:rPr lang="en-US" sz="2625" kern="0" spc="94" dirty="0">
                 <a:solidFill>
                   <a:srgbClr val="455A64"/>
                 </a:solidFill>
@@ -3537,7 +3183,7 @@
             <a:endParaRPr lang="en-US" sz="2625" dirty="0"/>
           </a:p>
           <a:p>
-            <a:pPr algn="l" marL="342900" indent="-342900">
+            <a:pPr marL="342900" indent="-342900" algn="l">
               <a:lnSpc>
                 <a:spcPct val="135000"/>
               </a:lnSpc>
@@ -3545,7 +3191,7 @@
               <a:buChar char="•"/>
             </a:pPr>
             <a:r>
-              <a:rPr lang="en-US" sz="2625" spc="94" kern="0" dirty="0">
+              <a:rPr lang="en-US" sz="2625" kern="0" spc="94" dirty="0">
                 <a:solidFill>
                   <a:srgbClr val="455A64"/>
                 </a:solidFill>
@@ -3555,14 +3201,8 @@
               </a:rPr>
               <a:t>Supports </a:t>
             </a:r>
-            <a:pPr algn="l" indent="0" marL="0">
-              <a:lnSpc>
-                <a:spcPct val="135000"/>
-              </a:lnSpc>
-              <a:buNone/>
-            </a:pPr>
-            <a:r>
-              <a:rPr lang="en-US" sz="2625" b="1" spc="94" kern="0" dirty="0">
+            <a:r>
+              <a:rPr lang="en-US" sz="2625" b="1" kern="0" spc="94" dirty="0">
                 <a:solidFill>
                   <a:srgbClr val="455A64"/>
                 </a:solidFill>
@@ -3572,14 +3212,8 @@
               </a:rPr>
               <a:t>x64</a:t>
             </a:r>
-            <a:pPr algn="l" indent="0" marL="0">
-              <a:lnSpc>
-                <a:spcPct val="135000"/>
-              </a:lnSpc>
-              <a:buNone/>
-            </a:pPr>
-            <a:r>
-              <a:rPr lang="en-US" sz="2625" spc="94" kern="0" dirty="0">
+            <a:r>
+              <a:rPr lang="en-US" sz="2625" kern="0" spc="94" dirty="0">
                 <a:solidFill>
                   <a:srgbClr val="455A64"/>
                 </a:solidFill>
@@ -3589,14 +3223,8 @@
               </a:rPr>
               <a:t> and </a:t>
             </a:r>
-            <a:pPr algn="l" indent="0" marL="0">
-              <a:lnSpc>
-                <a:spcPct val="135000"/>
-              </a:lnSpc>
-              <a:buNone/>
-            </a:pPr>
-            <a:r>
-              <a:rPr lang="en-US" sz="2625" b="1" spc="94" kern="0" dirty="0">
+            <a:r>
+              <a:rPr lang="en-US" sz="2625" b="1" kern="0" spc="94" dirty="0">
                 <a:solidFill>
                   <a:srgbClr val="455A64"/>
                 </a:solidFill>
@@ -3606,14 +3234,8 @@
               </a:rPr>
               <a:t>Arm64</a:t>
             </a:r>
-            <a:pPr algn="l" indent="0" marL="0">
-              <a:lnSpc>
-                <a:spcPct val="135000"/>
-              </a:lnSpc>
-              <a:buNone/>
-            </a:pPr>
-            <a:r>
-              <a:rPr lang="en-US" sz="2625" spc="94" kern="0" dirty="0">
+            <a:r>
+              <a:rPr lang="en-US" sz="2625" kern="0" spc="94" dirty="0">
                 <a:solidFill>
                   <a:srgbClr val="455A64"/>
                 </a:solidFill>
@@ -3648,14 +3270,14 @@
           <a:bodyPr wrap="square" lIns="0" tIns="0" rIns="0" bIns="0" rtlCol="0" anchor="t"/>
           <a:lstStyle/>
           <a:p>
-            <a:pPr algn="l" indent="0" marL="0">
+            <a:pPr marL="0" indent="0" algn="l">
               <a:lnSpc>
                 <a:spcPct val="238000"/>
               </a:lnSpc>
               <a:buNone/>
             </a:pPr>
             <a:r>
-              <a:rPr lang="en-US" sz="1575" spc="94" kern="0" dirty="0">
+              <a:rPr lang="en-US" sz="1575" kern="0" spc="94" dirty="0">
                 <a:solidFill>
                   <a:srgbClr val="6A7A7D"/>
                 </a:solidFill>
@@ -3689,7 +3311,7 @@
           </a:prstGeom>
           <a:extLst>
             <a:ext uri="{C572A759-6A51-4108-AA02-DFA0A04FC94B}">
-              <ma14:wrappingTextBoxFlag xmlns:ma14="http://schemas.microsoft.com/office/mac/drawingml/2011/main" val="0"/>
+              <ma14:wrappingTextBoxFlag xmlns:ma14="http://schemas.microsoft.com/office/mac/drawingml/2011/main" xmlns="" val="0"/>
             </a:ext>
           </a:extLst>
         </p:spPr>
@@ -3707,7 +3329,7 @@
           <a:p>
             <a:pPr algn="r"/>
             <a:fld id="{F7021451-1387-4CA6-816F-3879F97B5CBC}" type="slidenum">
-              <a:rPr b="0" lang="en-US"/>
+              <a:rPr lang="en-US" b="0"/>
               <a:t>5</a:t>
             </a:fld>
             <a:endParaRPr lang="en-US"/>
@@ -3728,7 +3350,7 @@
     <p:bg>
       <p:bgPr>
         <a:blipFill dpi="0" rotWithShape="1">
-          <a:blip r:embed="rId1">
+          <a:blip r:embed="rId3">
             <a:lum/>
           </a:blip>
           <a:srcRect/>
@@ -3774,14 +3396,14 @@
           <a:bodyPr wrap="square" lIns="0" tIns="0" rIns="0" bIns="0" rtlCol="0" anchor="t"/>
           <a:lstStyle/>
           <a:p>
-            <a:pPr algn="ctr" indent="0" marL="0">
+            <a:pPr marL="0" indent="0" algn="ctr">
               <a:lnSpc>
                 <a:spcPct val="135000"/>
               </a:lnSpc>
               <a:buNone/>
             </a:pPr>
             <a:r>
-              <a:rPr lang="en-US" sz="4725" b="1" spc="94" kern="0" dirty="0">
+              <a:rPr lang="en-US" sz="4725" b="1" kern="0" spc="94" dirty="0">
                 <a:solidFill>
                   <a:srgbClr val="FFF8E1"/>
                 </a:solidFill>
@@ -3789,24 +3411,7 @@
                 <a:ea typeface="Lato" pitchFamily="34" charset="-122"/>
                 <a:cs typeface="Lato" pitchFamily="34" charset="-120"/>
               </a:rPr>
-              <a:t>🚀</a:t>
-            </a:r>
-            <a:pPr algn="ctr" indent="0" marL="0">
-              <a:lnSpc>
-                <a:spcPct val="135000"/>
-              </a:lnSpc>
-              <a:buNone/>
-            </a:pPr>
-            <a:r>
-              <a:rPr lang="en-US" sz="4725" b="1" spc="94" kern="0" dirty="0">
-                <a:solidFill>
-                  <a:srgbClr val="FFF8E1"/>
-                </a:solidFill>
-                <a:latin typeface="Lato" pitchFamily="34" charset="0"/>
-                <a:ea typeface="Lato" pitchFamily="34" charset="-122"/>
-                <a:cs typeface="Lato" pitchFamily="34" charset="-120"/>
-              </a:rPr>
-              <a:t> Demo Time</a:t>
+              <a:t>🚀 Demo Time</a:t>
             </a:r>
             <a:endParaRPr lang="en-US" sz="4725" dirty="0"/>
           </a:p>
@@ -3833,14 +3438,14 @@
           <a:bodyPr wrap="square" lIns="0" tIns="0" rIns="0" bIns="0" rtlCol="0" anchor="t"/>
           <a:lstStyle/>
           <a:p>
-            <a:pPr algn="ctr" indent="0" marL="0">
+            <a:pPr marL="0" indent="0" algn="ctr">
               <a:lnSpc>
                 <a:spcPct val="135000"/>
               </a:lnSpc>
               <a:buNone/>
             </a:pPr>
             <a:r>
-              <a:rPr lang="en-US" sz="3413" b="1" spc="94" kern="0" dirty="0">
+              <a:rPr lang="en-US" sz="3413" b="1" kern="0" spc="94" dirty="0">
                 <a:solidFill>
                   <a:srgbClr val="FFF8E1"/>
                 </a:solidFill>
@@ -3874,7 +3479,7 @@
           </a:prstGeom>
           <a:extLst>
             <a:ext uri="{C572A759-6A51-4108-AA02-DFA0A04FC94B}">
-              <ma14:wrappingTextBoxFlag xmlns:ma14="http://schemas.microsoft.com/office/mac/drawingml/2011/main" val="0"/>
+              <ma14:wrappingTextBoxFlag xmlns:ma14="http://schemas.microsoft.com/office/mac/drawingml/2011/main" xmlns="" val="0"/>
             </a:ext>
           </a:extLst>
         </p:spPr>
@@ -3892,7 +3497,7 @@
           <a:p>
             <a:pPr algn="r"/>
             <a:fld id="{F7021451-1387-4CA6-816F-3879F97B5CBC}" type="slidenum">
-              <a:rPr b="0" lang="en-US"/>
+              <a:rPr lang="en-US" b="0"/>
               <a:t>6</a:t>
             </a:fld>
             <a:endParaRPr lang="en-US"/>
@@ -3913,7 +3518,7 @@
     <p:bg>
       <p:bgPr>
         <a:blipFill dpi="0" rotWithShape="1">
-          <a:blip r:embed="rId1">
+          <a:blip r:embed="rId3">
             <a:lum/>
           </a:blip>
           <a:srcRect/>
@@ -3959,14 +3564,14 @@
           <a:bodyPr wrap="square" lIns="0" tIns="0" rIns="0" bIns="0" rtlCol="0" anchor="t"/>
           <a:lstStyle/>
           <a:p>
-            <a:pPr algn="l" indent="0" marL="0">
+            <a:pPr marL="0" indent="0" algn="l">
               <a:lnSpc>
                 <a:spcPct val="216000"/>
               </a:lnSpc>
               <a:buNone/>
             </a:pPr>
             <a:r>
-              <a:rPr lang="en-US" sz="1733" b="1" spc="94" kern="0" dirty="0">
+              <a:rPr lang="en-US" sz="1733" b="1" kern="0" spc="94" dirty="0">
                 <a:solidFill>
                   <a:srgbClr val="6A7A7D"/>
                 </a:solidFill>
@@ -4001,14 +3606,14 @@
           <a:bodyPr wrap="square" lIns="0" tIns="0" rIns="0" bIns="0" rtlCol="0" anchor="t"/>
           <a:lstStyle/>
           <a:p>
-            <a:pPr algn="l" indent="0" marL="0">
+            <a:pPr marL="0" indent="0" algn="l">
               <a:lnSpc>
                 <a:spcPct val="135000"/>
               </a:lnSpc>
               <a:buNone/>
             </a:pPr>
             <a:r>
-              <a:rPr lang="en-US" sz="3938" b="1" spc="94" kern="0" dirty="0">
+              <a:rPr lang="en-US" sz="3938" b="1" kern="0" spc="94" dirty="0">
                 <a:solidFill>
                   <a:srgbClr val="455A64"/>
                 </a:solidFill>
@@ -4043,14 +3648,14 @@
           <a:bodyPr wrap="square" lIns="0" tIns="0" rIns="0" bIns="0" rtlCol="0" anchor="t"/>
           <a:lstStyle/>
           <a:p>
-            <a:pPr algn="l" indent="0" marL="0">
+            <a:pPr marL="0" indent="0" algn="l">
               <a:lnSpc>
                 <a:spcPct val="135000"/>
               </a:lnSpc>
               <a:buNone/>
             </a:pPr>
             <a:r>
-              <a:rPr lang="en-US" sz="2625" b="1" spc="94" kern="0" dirty="0">
+              <a:rPr lang="en-US" sz="2625" b="1" kern="0" spc="94" dirty="0">
                 <a:solidFill>
                   <a:srgbClr val="455A64"/>
                 </a:solidFill>
@@ -4060,14 +3665,8 @@
               </a:rPr>
               <a:t>Microsoft Store</a:t>
             </a:r>
-            <a:pPr algn="l" indent="0" marL="0">
-              <a:lnSpc>
-                <a:spcPct val="135000"/>
-              </a:lnSpc>
-              <a:buNone/>
-            </a:pPr>
-            <a:r>
-              <a:rPr lang="en-US" sz="2625" spc="94" kern="0" dirty="0">
+            <a:r>
+              <a:rPr lang="en-US" sz="2625" kern="0" spc="94" dirty="0">
                 <a:solidFill>
                   <a:srgbClr val="455A64"/>
                 </a:solidFill>
@@ -4077,21 +3676,15 @@
               </a:rPr>
               <a:t> — </a:t>
             </a:r>
-            <a:pPr algn="l" indent="0" marL="0">
-              <a:lnSpc>
-                <a:spcPct val="135000"/>
-              </a:lnSpc>
-              <a:buNone/>
-            </a:pPr>
-            <a:r>
-              <a:rPr lang="en-US" sz="2625" u="sng" spc="94" kern="0" dirty="0">
+            <a:r>
+              <a:rPr lang="en-US" sz="2625" u="sng" kern="0" spc="94" dirty="0">
                 <a:solidFill>
                   <a:srgbClr val="0288D1"/>
                 </a:solidFill>
                 <a:latin typeface="Lato" pitchFamily="34" charset="0"/>
                 <a:ea typeface="Lato" pitchFamily="34" charset="-122"/>
                 <a:cs typeface="Lato" pitchFamily="34" charset="-120"/>
-                <a:hlinkClick r:id="rId2" invalidUrl="" action="" tgtFrame="" tooltip="" history="1" highlightClick="0" endSnd="0">
+                <a:hlinkClick r:id="rId4">
                   <a:extLst>
                     <a:ext uri="{A12FA001-AC4F-418D-AE19-62706E023703}">
                       <ahyp:hlinkClr xmlns:ahyp="http://schemas.microsoft.com/office/drawing/2018/hyperlinkcolor" val="tx"/>
@@ -4101,23 +3694,17 @@
               </a:rPr>
               <a:t>aka.ms/ai-dev-gallery-store</a:t>
             </a:r>
-            <a:pPr algn="l" indent="0" marL="0">
+            <a:endParaRPr lang="en-US" sz="2625" dirty="0"/>
+          </a:p>
+          <a:p>
+            <a:pPr marL="0" indent="0" algn="l">
               <a:lnSpc>
                 <a:spcPct val="135000"/>
               </a:lnSpc>
               <a:buNone/>
             </a:pPr>
-            <a:endParaRPr lang="en-US" sz="2625" dirty="0"/>
-          </a:p>
-          <a:p>
-            <a:pPr algn="l" indent="0" marL="0">
-              <a:lnSpc>
-                <a:spcPct val="135000"/>
-              </a:lnSpc>
-              <a:buNone/>
-            </a:pPr>
-            <a:r>
-              <a:rPr lang="en-US" sz="2625" b="1" spc="94" kern="0" dirty="0">
+            <a:r>
+              <a:rPr lang="en-US" sz="2625" b="1" kern="0" spc="94" dirty="0">
                 <a:solidFill>
                   <a:srgbClr val="455A64"/>
                 </a:solidFill>
@@ -4127,14 +3714,8 @@
               </a:rPr>
               <a:t>GitHub</a:t>
             </a:r>
-            <a:pPr algn="l" indent="0" marL="0">
-              <a:lnSpc>
-                <a:spcPct val="135000"/>
-              </a:lnSpc>
-              <a:buNone/>
-            </a:pPr>
-            <a:r>
-              <a:rPr lang="en-US" sz="2625" spc="94" kern="0" dirty="0">
+            <a:r>
+              <a:rPr lang="en-US" sz="2625" kern="0" spc="94" dirty="0">
                 <a:solidFill>
                   <a:srgbClr val="455A64"/>
                 </a:solidFill>
@@ -4144,21 +3725,15 @@
               </a:rPr>
               <a:t> — </a:t>
             </a:r>
-            <a:pPr algn="l" indent="0" marL="0">
-              <a:lnSpc>
-                <a:spcPct val="135000"/>
-              </a:lnSpc>
-              <a:buNone/>
-            </a:pPr>
-            <a:r>
-              <a:rPr lang="en-US" sz="2625" u="sng" spc="94" kern="0" dirty="0">
+            <a:r>
+              <a:rPr lang="en-US" sz="2625" u="sng" kern="0" spc="94" dirty="0">
                 <a:solidFill>
                   <a:srgbClr val="0288D1"/>
                 </a:solidFill>
                 <a:latin typeface="Lato" pitchFamily="34" charset="0"/>
                 <a:ea typeface="Lato" pitchFamily="34" charset="-122"/>
                 <a:cs typeface="Lato" pitchFamily="34" charset="-120"/>
-                <a:hlinkClick r:id="rId3" invalidUrl="" action="" tgtFrame="" tooltip="" history="1" highlightClick="0" endSnd="0">
+                <a:hlinkClick r:id="rId5">
                   <a:extLst>
                     <a:ext uri="{A12FA001-AC4F-418D-AE19-62706E023703}">
                       <ahyp:hlinkClr xmlns:ahyp="http://schemas.microsoft.com/office/drawing/2018/hyperlinkcolor" val="tx"/>
@@ -4168,23 +3743,17 @@
               </a:rPr>
               <a:t>github.com/microsoft/ai-dev-gallery</a:t>
             </a:r>
-            <a:pPr algn="l" indent="0" marL="0">
+            <a:endParaRPr lang="en-US" sz="2625" dirty="0"/>
+          </a:p>
+          <a:p>
+            <a:pPr marL="0" indent="0" algn="l">
               <a:lnSpc>
                 <a:spcPct val="135000"/>
               </a:lnSpc>
               <a:buNone/>
             </a:pPr>
-            <a:endParaRPr lang="en-US" sz="2625" dirty="0"/>
-          </a:p>
-          <a:p>
-            <a:pPr algn="l" indent="0" marL="0">
-              <a:lnSpc>
-                <a:spcPct val="135000"/>
-              </a:lnSpc>
-              <a:buNone/>
-            </a:pPr>
-            <a:r>
-              <a:rPr lang="en-US" sz="2625" b="1" spc="94" kern="0" dirty="0">
+            <a:r>
+              <a:rPr lang="en-US" sz="2625" b="1" kern="0" spc="94" dirty="0">
                 <a:solidFill>
                   <a:srgbClr val="455A64"/>
                 </a:solidFill>
@@ -4194,14 +3763,8 @@
               </a:rPr>
               <a:t>Windows AI Docs</a:t>
             </a:r>
-            <a:pPr algn="l" indent="0" marL="0">
-              <a:lnSpc>
-                <a:spcPct val="135000"/>
-              </a:lnSpc>
-              <a:buNone/>
-            </a:pPr>
-            <a:r>
-              <a:rPr lang="en-US" sz="2625" spc="94" kern="0" dirty="0">
+            <a:r>
+              <a:rPr lang="en-US" sz="2625" kern="0" spc="94" dirty="0">
                 <a:solidFill>
                   <a:srgbClr val="455A64"/>
                 </a:solidFill>
@@ -4211,21 +3774,15 @@
               </a:rPr>
               <a:t> — </a:t>
             </a:r>
-            <a:pPr algn="l" indent="0" marL="0">
-              <a:lnSpc>
-                <a:spcPct val="135000"/>
-              </a:lnSpc>
-              <a:buNone/>
-            </a:pPr>
-            <a:r>
-              <a:rPr lang="en-US" sz="2625" u="sng" spc="94" kern="0" dirty="0">
+            <a:r>
+              <a:rPr lang="en-US" sz="2625" u="sng" kern="0" spc="94" dirty="0">
                 <a:solidFill>
                   <a:srgbClr val="0288D1"/>
                 </a:solidFill>
                 <a:latin typeface="Lato" pitchFamily="34" charset="0"/>
                 <a:ea typeface="Lato" pitchFamily="34" charset="-122"/>
                 <a:cs typeface="Lato" pitchFamily="34" charset="-120"/>
-                <a:hlinkClick r:id="rId4" invalidUrl="" action="" tgtFrame="" tooltip="" history="1" highlightClick="0" endSnd="0">
+                <a:hlinkClick r:id="rId6">
                   <a:extLst>
                     <a:ext uri="{A12FA001-AC4F-418D-AE19-62706E023703}">
                       <ahyp:hlinkClr xmlns:ahyp="http://schemas.microsoft.com/office/drawing/2018/hyperlinkcolor" val="tx"/>
@@ -4260,14 +3817,14 @@
           <a:bodyPr wrap="square" lIns="0" tIns="0" rIns="0" bIns="0" rtlCol="0" anchor="t"/>
           <a:lstStyle/>
           <a:p>
-            <a:pPr algn="l" indent="0" marL="0">
+            <a:pPr marL="0" indent="0" algn="l">
               <a:lnSpc>
                 <a:spcPct val="238000"/>
               </a:lnSpc>
               <a:buNone/>
             </a:pPr>
             <a:r>
-              <a:rPr lang="en-US" sz="1575" spc="94" kern="0" dirty="0">
+              <a:rPr lang="en-US" sz="1575" kern="0" spc="94" dirty="0">
                 <a:solidFill>
                   <a:srgbClr val="6A7A7D"/>
                 </a:solidFill>
@@ -4301,7 +3858,7 @@
           </a:prstGeom>
           <a:extLst>
             <a:ext uri="{C572A759-6A51-4108-AA02-DFA0A04FC94B}">
-              <ma14:wrappingTextBoxFlag xmlns:ma14="http://schemas.microsoft.com/office/mac/drawingml/2011/main" val="0"/>
+              <ma14:wrappingTextBoxFlag xmlns:ma14="http://schemas.microsoft.com/office/mac/drawingml/2011/main" xmlns="" val="0"/>
             </a:ext>
           </a:extLst>
         </p:spPr>
@@ -4319,7 +3876,7 @@
           <a:p>
             <a:pPr algn="r"/>
             <a:fld id="{F7021451-1387-4CA6-816F-3879F97B5CBC}" type="slidenum">
-              <a:rPr b="0" lang="en-US"/>
+              <a:rPr lang="en-US" b="0"/>
               <a:t>7</a:t>
             </a:fld>
             <a:endParaRPr lang="en-US"/>
@@ -4340,7 +3897,7 @@
     <p:bg>
       <p:bgPr>
         <a:blipFill dpi="0" rotWithShape="1">
-          <a:blip r:embed="rId1">
+          <a:blip r:embed="rId3">
             <a:lum/>
           </a:blip>
           <a:srcRect/>
@@ -4386,14 +3943,14 @@
           <a:bodyPr wrap="square" lIns="0" tIns="0" rIns="0" bIns="0" rtlCol="0" anchor="t"/>
           <a:lstStyle/>
           <a:p>
-            <a:pPr algn="ctr" indent="0" marL="0">
+            <a:pPr marL="0" indent="0" algn="ctr">
               <a:lnSpc>
                 <a:spcPct val="135000"/>
               </a:lnSpc>
               <a:buNone/>
             </a:pPr>
             <a:r>
-              <a:rPr lang="en-US" sz="3938" b="1" spc="94" kern="0" dirty="0">
+              <a:rPr lang="en-US" sz="3938" b="1" kern="0" spc="94" dirty="0">
                 <a:solidFill>
                   <a:srgbClr val="FFF8E1"/>
                 </a:solidFill>
@@ -4428,14 +3985,14 @@
           <a:bodyPr wrap="square" lIns="0" tIns="0" rIns="0" bIns="0" rtlCol="0" anchor="t"/>
           <a:lstStyle/>
           <a:p>
-            <a:pPr algn="ctr" indent="0" marL="0">
+            <a:pPr marL="0" indent="0" algn="ctr">
               <a:lnSpc>
                 <a:spcPct val="135000"/>
               </a:lnSpc>
               <a:buNone/>
             </a:pPr>
             <a:r>
-              <a:rPr lang="en-US" sz="3413" b="1" spc="94" kern="0" dirty="0">
+              <a:rPr lang="en-US" sz="3413" b="1" kern="0" spc="94" dirty="0">
                 <a:solidFill>
                   <a:srgbClr val="FFF8E1"/>
                 </a:solidFill>
@@ -4470,21 +4027,21 @@
           <a:bodyPr wrap="square" lIns="0" tIns="0" rIns="0" bIns="0" rtlCol="0" anchor="t"/>
           <a:lstStyle/>
           <a:p>
-            <a:pPr algn="ctr" indent="0" marL="0">
+            <a:pPr marL="0" indent="0" algn="ctr">
               <a:lnSpc>
                 <a:spcPct val="135000"/>
               </a:lnSpc>
               <a:buNone/>
             </a:pPr>
             <a:r>
-              <a:rPr lang="en-US" sz="2625" u="sng" spc="94" kern="0" dirty="0">
+              <a:rPr lang="en-US" sz="2625" u="sng" kern="0" spc="94" dirty="0">
                 <a:solidFill>
                   <a:srgbClr val="81D4FA"/>
                 </a:solidFill>
                 <a:latin typeface="Lato" pitchFamily="34" charset="0"/>
                 <a:ea typeface="Lato" pitchFamily="34" charset="-122"/>
                 <a:cs typeface="Lato" pitchFamily="34" charset="-120"/>
-                <a:hlinkClick r:id="rId2" invalidUrl="" action="" tgtFrame="" tooltip="" history="1" highlightClick="0" endSnd="0">
+                <a:hlinkClick r:id="rId4">
                   <a:extLst>
                     <a:ext uri="{A12FA001-AC4F-418D-AE19-62706E023703}">
                       <ahyp:hlinkClr xmlns:ahyp="http://schemas.microsoft.com/office/drawing/2018/hyperlinkcolor" val="tx"/>
@@ -4494,14 +4051,8 @@
               </a:rPr>
               <a:t>alvinashcraft.com</a:t>
             </a:r>
-            <a:pPr algn="ctr" indent="0" marL="0">
-              <a:lnSpc>
-                <a:spcPct val="135000"/>
-              </a:lnSpc>
-              <a:buNone/>
-            </a:pPr>
-            <a:r>
-              <a:rPr lang="en-US" sz="2625" spc="94" kern="0" dirty="0">
+            <a:r>
+              <a:rPr lang="en-US" sz="2625" kern="0" spc="94" dirty="0">
                 <a:solidFill>
                   <a:srgbClr val="FFF8E1"/>
                 </a:solidFill>
@@ -4511,21 +4062,15 @@
               </a:rPr>
               <a:t> · </a:t>
             </a:r>
-            <a:pPr algn="ctr" indent="0" marL="0">
-              <a:lnSpc>
-                <a:spcPct val="135000"/>
-              </a:lnSpc>
-              <a:buNone/>
-            </a:pPr>
-            <a:r>
-              <a:rPr lang="en-US" sz="2625" u="sng" spc="94" kern="0" dirty="0">
+            <a:r>
+              <a:rPr lang="en-US" sz="2625" u="sng" kern="0" spc="94" dirty="0">
                 <a:solidFill>
                   <a:srgbClr val="81D4FA"/>
                 </a:solidFill>
                 <a:latin typeface="Lato" pitchFamily="34" charset="0"/>
                 <a:ea typeface="Lato" pitchFamily="34" charset="-122"/>
                 <a:cs typeface="Lato" pitchFamily="34" charset="-120"/>
-                <a:hlinkClick r:id="rId3" invalidUrl="" action="" tgtFrame="" tooltip="" history="1" highlightClick="0" endSnd="0">
+                <a:hlinkClick r:id="rId5">
                   <a:extLst>
                     <a:ext uri="{A12FA001-AC4F-418D-AE19-62706E023703}">
                       <ahyp:hlinkClr xmlns:ahyp="http://schemas.microsoft.com/office/drawing/2018/hyperlinkcolor" val="tx"/>
@@ -4559,7 +4104,7 @@
           </a:prstGeom>
           <a:extLst>
             <a:ext uri="{C572A759-6A51-4108-AA02-DFA0A04FC94B}">
-              <ma14:wrappingTextBoxFlag xmlns:ma14="http://schemas.microsoft.com/office/mac/drawingml/2011/main" val="0"/>
+              <ma14:wrappingTextBoxFlag xmlns:ma14="http://schemas.microsoft.com/office/mac/drawingml/2011/main" xmlns="" val="0"/>
             </a:ext>
           </a:extLst>
         </p:spPr>
@@ -4577,7 +4122,7 @@
           <a:p>
             <a:pPr algn="r"/>
             <a:fld id="{F7021451-1387-4CA6-816F-3879F97B5CBC}" type="slidenum">
-              <a:rPr b="0" lang="en-US"/>
+              <a:rPr lang="en-US" b="0"/>
               <a:t>8</a:t>
             </a:fld>
             <a:endParaRPr lang="en-US"/>
@@ -4885,4 +4430,319 @@
     </a:ext>
   </a:extLst>
 </a:theme>
+</file>
+
+<file path=ppt/theme/theme2.xml><?xml version="1.0" encoding="utf-8"?>
+<a:theme xmlns:a="http://schemas.openxmlformats.org/drawingml/2006/main" name="Office Theme">
+  <a:themeElements>
+    <a:clrScheme name="Office">
+      <a:dk1>
+        <a:sysClr val="windowText" lastClr="000000"/>
+      </a:dk1>
+      <a:lt1>
+        <a:sysClr val="window" lastClr="FFFFFF"/>
+      </a:lt1>
+      <a:dk2>
+        <a:srgbClr val="0E2841"/>
+      </a:dk2>
+      <a:lt2>
+        <a:srgbClr val="E8E8E8"/>
+      </a:lt2>
+      <a:accent1>
+        <a:srgbClr val="156082"/>
+      </a:accent1>
+      <a:accent2>
+        <a:srgbClr val="E97132"/>
+      </a:accent2>
+      <a:accent3>
+        <a:srgbClr val="196B24"/>
+      </a:accent3>
+      <a:accent4>
+        <a:srgbClr val="0F9ED5"/>
+      </a:accent4>
+      <a:accent5>
+        <a:srgbClr val="A02B93"/>
+      </a:accent5>
+      <a:accent6>
+        <a:srgbClr val="4EA72E"/>
+      </a:accent6>
+      <a:hlink>
+        <a:srgbClr val="467886"/>
+      </a:hlink>
+      <a:folHlink>
+        <a:srgbClr val="96607D"/>
+      </a:folHlink>
+    </a:clrScheme>
+    <a:fontScheme name="Office">
+      <a:majorFont>
+        <a:latin typeface="Aptos Display" panose="02110004020202020204"/>
+        <a:ea typeface=""/>
+        <a:cs typeface=""/>
+        <a:font script="Jpan" typeface="游ゴシック Light"/>
+        <a:font script="Hang" typeface="맑은 고딕"/>
+        <a:font script="Hans" typeface="等线 Light"/>
+        <a:font script="Hant" typeface="新細明體"/>
+        <a:font script="Arab" typeface="Times New Roman"/>
+        <a:font script="Hebr" typeface="Times New Roman"/>
+        <a:font script="Thai" typeface="Angsana New"/>
+        <a:font script="Ethi" typeface="Nyala"/>
+        <a:font script="Beng" typeface="Vrinda"/>
+        <a:font script="Gujr" typeface="Shruti"/>
+        <a:font script="Khmr" typeface="MoolBoran"/>
+        <a:font script="Knda" typeface="Tunga"/>
+        <a:font script="Guru" typeface="Raavi"/>
+        <a:font script="Cans" typeface="Euphemia"/>
+        <a:font script="Cher" typeface="Plantagenet Cherokee"/>
+        <a:font script="Yiii" typeface="Microsoft Yi Baiti"/>
+        <a:font script="Tibt" typeface="Microsoft Himalaya"/>
+        <a:font script="Thaa" typeface="MV Boli"/>
+        <a:font script="Deva" typeface="Mangal"/>
+        <a:font script="Telu" typeface="Gautami"/>
+        <a:font script="Taml" typeface="Latha"/>
+        <a:font script="Syrc" typeface="Estrangelo Edessa"/>
+        <a:font script="Orya" typeface="Kalinga"/>
+        <a:font script="Mlym" typeface="Kartika"/>
+        <a:font script="Laoo" typeface="DokChampa"/>
+        <a:font script="Sinh" typeface="Iskoola Pota"/>
+        <a:font script="Mong" typeface="Mongolian Baiti"/>
+        <a:font script="Viet" typeface="Times New Roman"/>
+        <a:font script="Uigh" typeface="Microsoft Uighur"/>
+        <a:font script="Geor" typeface="Sylfaen"/>
+        <a:font script="Armn" typeface="Arial"/>
+        <a:font script="Bugi" typeface="Leelawadee UI"/>
+        <a:font script="Bopo" typeface="Microsoft JhengHei"/>
+        <a:font script="Java" typeface="Javanese Text"/>
+        <a:font script="Lisu" typeface="Segoe UI"/>
+        <a:font script="Mymr" typeface="Myanmar Text"/>
+        <a:font script="Nkoo" typeface="Ebrima"/>
+        <a:font script="Olck" typeface="Nirmala UI"/>
+        <a:font script="Osma" typeface="Ebrima"/>
+        <a:font script="Phag" typeface="Phagspa"/>
+        <a:font script="Syrn" typeface="Estrangelo Edessa"/>
+        <a:font script="Syrj" typeface="Estrangelo Edessa"/>
+        <a:font script="Syre" typeface="Estrangelo Edessa"/>
+        <a:font script="Sora" typeface="Nirmala UI"/>
+        <a:font script="Tale" typeface="Microsoft Tai Le"/>
+        <a:font script="Talu" typeface="Microsoft New Tai Lue"/>
+        <a:font script="Tfng" typeface="Ebrima"/>
+      </a:majorFont>
+      <a:minorFont>
+        <a:latin typeface="Aptos" panose="02110004020202020204"/>
+        <a:ea typeface=""/>
+        <a:cs typeface=""/>
+        <a:font script="Jpan" typeface="游ゴシック"/>
+        <a:font script="Hang" typeface="맑은 고딕"/>
+        <a:font script="Hans" typeface="等线"/>
+        <a:font script="Hant" typeface="新細明體"/>
+        <a:font script="Arab" typeface="Arial"/>
+        <a:font script="Hebr" typeface="Arial"/>
+        <a:font script="Thai" typeface="Cordia New"/>
+        <a:font script="Ethi" typeface="Nyala"/>
+        <a:font script="Beng" typeface="Vrinda"/>
+        <a:font script="Gujr" typeface="Shruti"/>
+        <a:font script="Khmr" typeface="DaunPenh"/>
+        <a:font script="Knda" typeface="Tunga"/>
+        <a:font script="Guru" typeface="Raavi"/>
+        <a:font script="Cans" typeface="Euphemia"/>
+        <a:font script="Cher" typeface="Plantagenet Cherokee"/>
+        <a:font script="Yiii" typeface="Microsoft Yi Baiti"/>
+        <a:font script="Tibt" typeface="Microsoft Himalaya"/>
+        <a:font script="Thaa" typeface="MV Boli"/>
+        <a:font script="Deva" typeface="Mangal"/>
+        <a:font script="Telu" typeface="Gautami"/>
+        <a:font script="Taml" typeface="Latha"/>
+        <a:font script="Syrc" typeface="Estrangelo Edessa"/>
+        <a:font script="Orya" typeface="Kalinga"/>
+        <a:font script="Mlym" typeface="Kartika"/>
+        <a:font script="Laoo" typeface="DokChampa"/>
+        <a:font script="Sinh" typeface="Iskoola Pota"/>
+        <a:font script="Mong" typeface="Mongolian Baiti"/>
+        <a:font script="Viet" typeface="Arial"/>
+        <a:font script="Uigh" typeface="Microsoft Uighur"/>
+        <a:font script="Geor" typeface="Sylfaen"/>
+        <a:font script="Armn" typeface="Arial"/>
+        <a:font script="Bugi" typeface="Leelawadee UI"/>
+        <a:font script="Bopo" typeface="Microsoft JhengHei"/>
+        <a:font script="Java" typeface="Javanese Text"/>
+        <a:font script="Lisu" typeface="Segoe UI"/>
+        <a:font script="Mymr" typeface="Myanmar Text"/>
+        <a:font script="Nkoo" typeface="Ebrima"/>
+        <a:font script="Olck" typeface="Nirmala UI"/>
+        <a:font script="Osma" typeface="Ebrima"/>
+        <a:font script="Phag" typeface="Phagspa"/>
+        <a:font script="Syrn" typeface="Estrangelo Edessa"/>
+        <a:font script="Syrj" typeface="Estrangelo Edessa"/>
+        <a:font script="Syre" typeface="Estrangelo Edessa"/>
+        <a:font script="Sora" typeface="Nirmala UI"/>
+        <a:font script="Tale" typeface="Microsoft Tai Le"/>
+        <a:font script="Talu" typeface="Microsoft New Tai Lue"/>
+        <a:font script="Tfng" typeface="Ebrima"/>
+      </a:minorFont>
+    </a:fontScheme>
+    <a:fmtScheme name="Office">
+      <a:fillStyleLst>
+        <a:solidFill>
+          <a:schemeClr val="phClr"/>
+        </a:solidFill>
+        <a:gradFill rotWithShape="1">
+          <a:gsLst>
+            <a:gs pos="0">
+              <a:schemeClr val="phClr">
+                <a:lumMod val="110000"/>
+                <a:satMod val="105000"/>
+                <a:tint val="67000"/>
+              </a:schemeClr>
+            </a:gs>
+            <a:gs pos="50000">
+              <a:schemeClr val="phClr">
+                <a:lumMod val="105000"/>
+                <a:satMod val="103000"/>
+                <a:tint val="73000"/>
+              </a:schemeClr>
+            </a:gs>
+            <a:gs pos="100000">
+              <a:schemeClr val="phClr">
+                <a:lumMod val="105000"/>
+                <a:satMod val="109000"/>
+                <a:tint val="81000"/>
+              </a:schemeClr>
+            </a:gs>
+          </a:gsLst>
+          <a:lin ang="5400000" scaled="0"/>
+        </a:gradFill>
+        <a:gradFill rotWithShape="1">
+          <a:gsLst>
+            <a:gs pos="0">
+              <a:schemeClr val="phClr">
+                <a:satMod val="103000"/>
+                <a:lumMod val="102000"/>
+                <a:tint val="94000"/>
+              </a:schemeClr>
+            </a:gs>
+            <a:gs pos="50000">
+              <a:schemeClr val="phClr">
+                <a:satMod val="110000"/>
+                <a:lumMod val="100000"/>
+                <a:shade val="100000"/>
+              </a:schemeClr>
+            </a:gs>
+            <a:gs pos="100000">
+              <a:schemeClr val="phClr">
+                <a:lumMod val="99000"/>
+                <a:satMod val="120000"/>
+                <a:shade val="78000"/>
+              </a:schemeClr>
+            </a:gs>
+          </a:gsLst>
+          <a:lin ang="5400000" scaled="0"/>
+        </a:gradFill>
+      </a:fillStyleLst>
+      <a:lnStyleLst>
+        <a:ln w="12700" cap="flat" cmpd="sng" algn="ctr">
+          <a:solidFill>
+            <a:schemeClr val="phClr"/>
+          </a:solidFill>
+          <a:prstDash val="solid"/>
+          <a:miter lim="800000"/>
+        </a:ln>
+        <a:ln w="19050" cap="flat" cmpd="sng" algn="ctr">
+          <a:solidFill>
+            <a:schemeClr val="phClr"/>
+          </a:solidFill>
+          <a:prstDash val="solid"/>
+          <a:miter lim="800000"/>
+        </a:ln>
+        <a:ln w="25400" cap="flat" cmpd="sng" algn="ctr">
+          <a:solidFill>
+            <a:schemeClr val="phClr"/>
+          </a:solidFill>
+          <a:prstDash val="solid"/>
+          <a:miter lim="800000"/>
+        </a:ln>
+      </a:lnStyleLst>
+      <a:effectStyleLst>
+        <a:effectStyle>
+          <a:effectLst/>
+        </a:effectStyle>
+        <a:effectStyle>
+          <a:effectLst/>
+        </a:effectStyle>
+        <a:effectStyle>
+          <a:effectLst>
+            <a:outerShdw blurRad="57150" dist="19050" dir="5400000" algn="ctr" rotWithShape="0">
+              <a:srgbClr val="000000">
+                <a:alpha val="63000"/>
+              </a:srgbClr>
+            </a:outerShdw>
+          </a:effectLst>
+        </a:effectStyle>
+      </a:effectStyleLst>
+      <a:bgFillStyleLst>
+        <a:solidFill>
+          <a:schemeClr val="phClr"/>
+        </a:solidFill>
+        <a:solidFill>
+          <a:schemeClr val="phClr">
+            <a:tint val="95000"/>
+            <a:satMod val="170000"/>
+          </a:schemeClr>
+        </a:solidFill>
+        <a:gradFill rotWithShape="1">
+          <a:gsLst>
+            <a:gs pos="0">
+              <a:schemeClr val="phClr">
+                <a:tint val="93000"/>
+                <a:satMod val="150000"/>
+                <a:shade val="98000"/>
+                <a:lumMod val="102000"/>
+              </a:schemeClr>
+            </a:gs>
+            <a:gs pos="50000">
+              <a:schemeClr val="phClr">
+                <a:tint val="98000"/>
+                <a:satMod val="130000"/>
+                <a:shade val="90000"/>
+                <a:lumMod val="103000"/>
+              </a:schemeClr>
+            </a:gs>
+            <a:gs pos="100000">
+              <a:schemeClr val="phClr">
+                <a:shade val="63000"/>
+                <a:satMod val="120000"/>
+              </a:schemeClr>
+            </a:gs>
+          </a:gsLst>
+          <a:lin ang="5400000" scaled="0"/>
+        </a:gradFill>
+      </a:bgFillStyleLst>
+    </a:fmtScheme>
+  </a:themeElements>
+  <a:objectDefaults>
+    <a:lnDef>
+      <a:spPr/>
+      <a:bodyPr/>
+      <a:lstStyle/>
+      <a:style>
+        <a:lnRef idx="2">
+          <a:schemeClr val="accent1"/>
+        </a:lnRef>
+        <a:fillRef idx="0">
+          <a:schemeClr val="accent1"/>
+        </a:fillRef>
+        <a:effectRef idx="1">
+          <a:schemeClr val="accent1"/>
+        </a:effectRef>
+        <a:fontRef idx="minor">
+          <a:schemeClr val="tx1"/>
+        </a:fontRef>
+      </a:style>
+    </a:lnDef>
+  </a:objectDefaults>
+  <a:extraClrSchemeLst/>
+  <a:extLst>
+    <a:ext uri="{05A4C25C-085E-4340-85A3-A5531E510DB2}">
+      <thm15:themeFamily xmlns:thm15="http://schemas.microsoft.com/office/thememl/2012/main" name="Office Theme" id="{2E142A2C-CD16-42D6-873A-C26D2A0506FA}" vid="{1BDDFF52-6CD6-40A5-AB3C-68EB2F1E4D0A}"/>
+    </a:ext>
+  </a:extLst>
+</a:theme>
 </file>
</xml_diff>